<commit_message>
Mostra o prazo de cada metrica no PMO dos dashboards
Cada metrica passa a exibir focal e prazo na propria linha, com o prazo
em ambar quando ainda esta em andamento e em cinza quando concluida.

Co-Authored-By: Claude Opus 5 <noreply@anthropic.com>
Claude-Session: https://claude.ai/code/session_01LiBTDxNxgFCPijAoYiizN1
</commit_message>
<xml_diff>
--- a/apresentacoes/Planejamento_PMO.pptx
+++ b/apresentacoes/Planejamento_PMO.pptx
@@ -3277,7 +3277,7 @@
                 <a:ea typeface="Calibri" pitchFamily="34" charset="-122"/>
                 <a:cs typeface="Calibri" pitchFamily="34" charset="-120"/>
               </a:rPr>
-              <a:t>Periodicidade a definir  ·  prazos 05 e 10/10</a:t>
+              <a:t>Periodicidade a definir</a:t>
             </a:r>
             <a:endParaRPr lang="en-US" sz="900" dirty="0"/>
           </a:p>
@@ -3323,7 +3323,7 @@
         <p:spPr>
           <a:xfrm>
             <a:off x="841248" y="2871216"/>
-            <a:ext cx="2953512" cy="201168"/>
+            <a:ext cx="1947672" cy="201168"/>
           </a:xfrm>
           <a:prstGeom prst="rect">
             <a:avLst/>
@@ -3355,7 +3355,85 @@
       </p:sp>
       <p:sp>
         <p:nvSpPr>
-          <p:cNvPr id="17" name="Shape 14"/>
+          <p:cNvPr id="17" name="Text 14"/>
+          <p:cNvSpPr txBox="1"/>
+          <p:nvPr/>
+        </p:nvSpPr>
+        <p:spPr>
+          <a:xfrm>
+            <a:off x="2679192" y="2871216"/>
+            <a:ext cx="640080" cy="201168"/>
+          </a:xfrm>
+          <a:prstGeom prst="rect">
+            <a:avLst/>
+          </a:prstGeom>
+          <a:noFill/>
+          <a:ln/>
+        </p:spPr>
+        <p:txBody>
+          <a:bodyPr wrap="square" lIns="0" tIns="0" rIns="0" bIns="0" rtlCol="0" anchor="ctr"/>
+          <a:lstStyle/>
+          <a:p>
+            <a:pPr algn="r" indent="0" marL="0">
+              <a:buNone/>
+            </a:pPr>
+            <a:r>
+              <a:rPr lang="en-US" sz="700" b="1" spc="80" kern="0" dirty="0">
+                <a:solidFill>
+                  <a:srgbClr val="93A9C6"/>
+                </a:solidFill>
+                <a:latin typeface="Calibri" pitchFamily="34" charset="0"/>
+                <a:ea typeface="Calibri" pitchFamily="34" charset="-122"/>
+                <a:cs typeface="Calibri" pitchFamily="34" charset="-120"/>
+              </a:rPr>
+              <a:t>FOCAL</a:t>
+            </a:r>
+            <a:endParaRPr lang="en-US" sz="700" dirty="0"/>
+          </a:p>
+        </p:txBody>
+      </p:sp>
+      <p:sp>
+        <p:nvSpPr>
+          <p:cNvPr id="18" name="Text 15"/>
+          <p:cNvSpPr txBox="1"/>
+          <p:nvPr/>
+        </p:nvSpPr>
+        <p:spPr>
+          <a:xfrm>
+            <a:off x="3392424" y="2871216"/>
+            <a:ext cx="402336" cy="201168"/>
+          </a:xfrm>
+          <a:prstGeom prst="rect">
+            <a:avLst/>
+          </a:prstGeom>
+          <a:noFill/>
+          <a:ln/>
+        </p:spPr>
+        <p:txBody>
+          <a:bodyPr wrap="square" lIns="0" tIns="0" rIns="0" bIns="0" rtlCol="0" anchor="ctr"/>
+          <a:lstStyle/>
+          <a:p>
+            <a:pPr algn="r" indent="0" marL="0">
+              <a:buNone/>
+            </a:pPr>
+            <a:r>
+              <a:rPr lang="en-US" sz="700" b="1" spc="80" kern="0" dirty="0">
+                <a:solidFill>
+                  <a:srgbClr val="93A9C6"/>
+                </a:solidFill>
+                <a:latin typeface="Calibri" pitchFamily="34" charset="0"/>
+                <a:ea typeface="Calibri" pitchFamily="34" charset="-122"/>
+                <a:cs typeface="Calibri" pitchFamily="34" charset="-120"/>
+              </a:rPr>
+              <a:t>PRAZO</a:t>
+            </a:r>
+            <a:endParaRPr lang="en-US" sz="700" dirty="0"/>
+          </a:p>
+        </p:txBody>
+      </p:sp>
+      <p:sp>
+        <p:nvSpPr>
+          <p:cNvPr id="19" name="Shape 16"/>
           <p:cNvSpPr/>
           <p:nvPr/>
         </p:nvSpPr>
@@ -3377,14 +3455,14 @@
       </p:sp>
       <p:sp>
         <p:nvSpPr>
-          <p:cNvPr id="18" name="Text 15"/>
+          <p:cNvPr id="20" name="Text 17"/>
           <p:cNvSpPr txBox="1"/>
           <p:nvPr/>
         </p:nvSpPr>
         <p:spPr>
           <a:xfrm>
             <a:off x="1042416" y="3090672"/>
-            <a:ext cx="2084832" cy="201168"/>
+            <a:ext cx="1581912" cy="201168"/>
           </a:xfrm>
           <a:prstGeom prst="rect">
             <a:avLst/>
@@ -3416,13 +3494,13 @@
       </p:sp>
       <p:sp>
         <p:nvSpPr>
-          <p:cNvPr id="19" name="Text 16"/>
-          <p:cNvSpPr txBox="1"/>
-          <p:nvPr/>
-        </p:nvSpPr>
-        <p:spPr>
-          <a:xfrm>
-            <a:off x="3154680" y="3090672"/>
+          <p:cNvPr id="21" name="Text 18"/>
+          <p:cNvSpPr txBox="1"/>
+          <p:nvPr/>
+        </p:nvSpPr>
+        <p:spPr>
+          <a:xfrm>
+            <a:off x="2679192" y="3090672"/>
             <a:ext cx="640080" cy="201168"/>
           </a:xfrm>
           <a:prstGeom prst="rect">
@@ -3455,7 +3533,46 @@
       </p:sp>
       <p:sp>
         <p:nvSpPr>
-          <p:cNvPr id="20" name="Shape 17"/>
+          <p:cNvPr id="22" name="Text 19"/>
+          <p:cNvSpPr txBox="1"/>
+          <p:nvPr/>
+        </p:nvSpPr>
+        <p:spPr>
+          <a:xfrm>
+            <a:off x="3392424" y="3090672"/>
+            <a:ext cx="402336" cy="201168"/>
+          </a:xfrm>
+          <a:prstGeom prst="rect">
+            <a:avLst/>
+          </a:prstGeom>
+          <a:noFill/>
+          <a:ln/>
+        </p:spPr>
+        <p:txBody>
+          <a:bodyPr wrap="square" lIns="0" tIns="0" rIns="0" bIns="0" rtlCol="0" anchor="ctr"/>
+          <a:lstStyle/>
+          <a:p>
+            <a:pPr algn="r" indent="0" marL="0">
+              <a:buNone/>
+            </a:pPr>
+            <a:r>
+              <a:rPr lang="en-US" sz="900" b="1" dirty="0">
+                <a:solidFill>
+                  <a:srgbClr val="E9A13B"/>
+                </a:solidFill>
+                <a:latin typeface="Calibri" pitchFamily="34" charset="0"/>
+                <a:ea typeface="Calibri" pitchFamily="34" charset="-122"/>
+                <a:cs typeface="Calibri" pitchFamily="34" charset="-120"/>
+              </a:rPr>
+              <a:t>10/10</a:t>
+            </a:r>
+            <a:endParaRPr lang="en-US" sz="900" dirty="0"/>
+          </a:p>
+        </p:txBody>
+      </p:sp>
+      <p:sp>
+        <p:nvSpPr>
+          <p:cNvPr id="23" name="Shape 20"/>
           <p:cNvSpPr/>
           <p:nvPr/>
         </p:nvSpPr>
@@ -3477,14 +3594,14 @@
       </p:sp>
       <p:sp>
         <p:nvSpPr>
-          <p:cNvPr id="21" name="Text 18"/>
+          <p:cNvPr id="24" name="Text 21"/>
           <p:cNvSpPr txBox="1"/>
           <p:nvPr/>
         </p:nvSpPr>
         <p:spPr>
           <a:xfrm>
             <a:off x="1042416" y="3291840"/>
-            <a:ext cx="2084832" cy="201168"/>
+            <a:ext cx="1581912" cy="201168"/>
           </a:xfrm>
           <a:prstGeom prst="rect">
             <a:avLst/>
@@ -3516,13 +3633,13 @@
       </p:sp>
       <p:sp>
         <p:nvSpPr>
-          <p:cNvPr id="22" name="Text 19"/>
-          <p:cNvSpPr txBox="1"/>
-          <p:nvPr/>
-        </p:nvSpPr>
-        <p:spPr>
-          <a:xfrm>
-            <a:off x="3154680" y="3291840"/>
+          <p:cNvPr id="25" name="Text 22"/>
+          <p:cNvSpPr txBox="1"/>
+          <p:nvPr/>
+        </p:nvSpPr>
+        <p:spPr>
+          <a:xfrm>
+            <a:off x="2679192" y="3291840"/>
             <a:ext cx="640080" cy="201168"/>
           </a:xfrm>
           <a:prstGeom prst="rect">
@@ -3555,7 +3672,46 @@
       </p:sp>
       <p:sp>
         <p:nvSpPr>
-          <p:cNvPr id="23" name="Shape 20"/>
+          <p:cNvPr id="26" name="Text 23"/>
+          <p:cNvSpPr txBox="1"/>
+          <p:nvPr/>
+        </p:nvSpPr>
+        <p:spPr>
+          <a:xfrm>
+            <a:off x="3392424" y="3291840"/>
+            <a:ext cx="402336" cy="201168"/>
+          </a:xfrm>
+          <a:prstGeom prst="rect">
+            <a:avLst/>
+          </a:prstGeom>
+          <a:noFill/>
+          <a:ln/>
+        </p:spPr>
+        <p:txBody>
+          <a:bodyPr wrap="square" lIns="0" tIns="0" rIns="0" bIns="0" rtlCol="0" anchor="ctr"/>
+          <a:lstStyle/>
+          <a:p>
+            <a:pPr algn="r" indent="0" marL="0">
+              <a:buNone/>
+            </a:pPr>
+            <a:r>
+              <a:rPr lang="en-US" sz="900" b="1" dirty="0">
+                <a:solidFill>
+                  <a:srgbClr val="E9A13B"/>
+                </a:solidFill>
+                <a:latin typeface="Calibri" pitchFamily="34" charset="0"/>
+                <a:ea typeface="Calibri" pitchFamily="34" charset="-122"/>
+                <a:cs typeface="Calibri" pitchFamily="34" charset="-120"/>
+              </a:rPr>
+              <a:t>10/10</a:t>
+            </a:r>
+            <a:endParaRPr lang="en-US" sz="900" dirty="0"/>
+          </a:p>
+        </p:txBody>
+      </p:sp>
+      <p:sp>
+        <p:nvSpPr>
+          <p:cNvPr id="27" name="Shape 24"/>
           <p:cNvSpPr/>
           <p:nvPr/>
         </p:nvSpPr>
@@ -3577,14 +3733,14 @@
       </p:sp>
       <p:sp>
         <p:nvSpPr>
-          <p:cNvPr id="24" name="Text 21"/>
+          <p:cNvPr id="28" name="Text 25"/>
           <p:cNvSpPr txBox="1"/>
           <p:nvPr/>
         </p:nvSpPr>
         <p:spPr>
           <a:xfrm>
             <a:off x="1042416" y="3493008"/>
-            <a:ext cx="2084832" cy="201168"/>
+            <a:ext cx="1581912" cy="201168"/>
           </a:xfrm>
           <a:prstGeom prst="rect">
             <a:avLst/>
@@ -3616,13 +3772,13 @@
       </p:sp>
       <p:sp>
         <p:nvSpPr>
-          <p:cNvPr id="25" name="Text 22"/>
-          <p:cNvSpPr txBox="1"/>
-          <p:nvPr/>
-        </p:nvSpPr>
-        <p:spPr>
-          <a:xfrm>
-            <a:off x="3154680" y="3493008"/>
+          <p:cNvPr id="29" name="Text 26"/>
+          <p:cNvSpPr txBox="1"/>
+          <p:nvPr/>
+        </p:nvSpPr>
+        <p:spPr>
+          <a:xfrm>
+            <a:off x="2679192" y="3493008"/>
             <a:ext cx="640080" cy="201168"/>
           </a:xfrm>
           <a:prstGeom prst="rect">
@@ -3655,7 +3811,46 @@
       </p:sp>
       <p:sp>
         <p:nvSpPr>
-          <p:cNvPr id="26" name="Shape 23"/>
+          <p:cNvPr id="30" name="Text 27"/>
+          <p:cNvSpPr txBox="1"/>
+          <p:nvPr/>
+        </p:nvSpPr>
+        <p:spPr>
+          <a:xfrm>
+            <a:off x="3392424" y="3493008"/>
+            <a:ext cx="402336" cy="201168"/>
+          </a:xfrm>
+          <a:prstGeom prst="rect">
+            <a:avLst/>
+          </a:prstGeom>
+          <a:noFill/>
+          <a:ln/>
+        </p:spPr>
+        <p:txBody>
+          <a:bodyPr wrap="square" lIns="0" tIns="0" rIns="0" bIns="0" rtlCol="0" anchor="ctr"/>
+          <a:lstStyle/>
+          <a:p>
+            <a:pPr algn="r" indent="0" marL="0">
+              <a:buNone/>
+            </a:pPr>
+            <a:r>
+              <a:rPr lang="en-US" sz="900" b="1" dirty="0">
+                <a:solidFill>
+                  <a:srgbClr val="E9A13B"/>
+                </a:solidFill>
+                <a:latin typeface="Calibri" pitchFamily="34" charset="0"/>
+                <a:ea typeface="Calibri" pitchFamily="34" charset="-122"/>
+                <a:cs typeface="Calibri" pitchFamily="34" charset="-120"/>
+              </a:rPr>
+              <a:t>10/10</a:t>
+            </a:r>
+            <a:endParaRPr lang="en-US" sz="900" dirty="0"/>
+          </a:p>
+        </p:txBody>
+      </p:sp>
+      <p:sp>
+        <p:nvSpPr>
+          <p:cNvPr id="31" name="Shape 28"/>
           <p:cNvSpPr/>
           <p:nvPr/>
         </p:nvSpPr>
@@ -3677,14 +3872,14 @@
       </p:sp>
       <p:sp>
         <p:nvSpPr>
-          <p:cNvPr id="27" name="Text 24"/>
+          <p:cNvPr id="32" name="Text 29"/>
           <p:cNvSpPr txBox="1"/>
           <p:nvPr/>
         </p:nvSpPr>
         <p:spPr>
           <a:xfrm>
             <a:off x="1042416" y="3694176"/>
-            <a:ext cx="2084832" cy="201168"/>
+            <a:ext cx="1581912" cy="201168"/>
           </a:xfrm>
           <a:prstGeom prst="rect">
             <a:avLst/>
@@ -3716,13 +3911,13 @@
       </p:sp>
       <p:sp>
         <p:nvSpPr>
-          <p:cNvPr id="28" name="Text 25"/>
-          <p:cNvSpPr txBox="1"/>
-          <p:nvPr/>
-        </p:nvSpPr>
-        <p:spPr>
-          <a:xfrm>
-            <a:off x="3154680" y="3694176"/>
+          <p:cNvPr id="33" name="Text 30"/>
+          <p:cNvSpPr txBox="1"/>
+          <p:nvPr/>
+        </p:nvSpPr>
+        <p:spPr>
+          <a:xfrm>
+            <a:off x="2679192" y="3694176"/>
             <a:ext cx="640080" cy="201168"/>
           </a:xfrm>
           <a:prstGeom prst="rect">
@@ -3755,14 +3950,53 @@
       </p:sp>
       <p:sp>
         <p:nvSpPr>
-          <p:cNvPr id="29" name="Text 26"/>
+          <p:cNvPr id="34" name="Text 31"/>
+          <p:cNvSpPr txBox="1"/>
+          <p:nvPr/>
+        </p:nvSpPr>
+        <p:spPr>
+          <a:xfrm>
+            <a:off x="3392424" y="3694176"/>
+            <a:ext cx="402336" cy="201168"/>
+          </a:xfrm>
+          <a:prstGeom prst="rect">
+            <a:avLst/>
+          </a:prstGeom>
+          <a:noFill/>
+          <a:ln/>
+        </p:spPr>
+        <p:txBody>
+          <a:bodyPr wrap="square" lIns="0" tIns="0" rIns="0" bIns="0" rtlCol="0" anchor="ctr"/>
+          <a:lstStyle/>
+          <a:p>
+            <a:pPr algn="r" indent="0" marL="0">
+              <a:buNone/>
+            </a:pPr>
+            <a:r>
+              <a:rPr lang="en-US" sz="900" b="1" dirty="0">
+                <a:solidFill>
+                  <a:srgbClr val="E9A13B"/>
+                </a:solidFill>
+                <a:latin typeface="Calibri" pitchFamily="34" charset="0"/>
+                <a:ea typeface="Calibri" pitchFamily="34" charset="-122"/>
+                <a:cs typeface="Calibri" pitchFamily="34" charset="-120"/>
+              </a:rPr>
+              <a:t>10/10</a:t>
+            </a:r>
+            <a:endParaRPr lang="en-US" sz="900" dirty="0"/>
+          </a:p>
+        </p:txBody>
+      </p:sp>
+      <p:sp>
+        <p:nvSpPr>
+          <p:cNvPr id="35" name="Text 32"/>
           <p:cNvSpPr txBox="1"/>
           <p:nvPr/>
         </p:nvSpPr>
         <p:spPr>
           <a:xfrm>
             <a:off x="841248" y="3931920"/>
-            <a:ext cx="2953512" cy="201168"/>
+            <a:ext cx="1947672" cy="201168"/>
           </a:xfrm>
           <a:prstGeom prst="rect">
             <a:avLst/>
@@ -3794,7 +4028,7 @@
       </p:sp>
       <p:sp>
         <p:nvSpPr>
-          <p:cNvPr id="30" name="Shape 27"/>
+          <p:cNvPr id="36" name="Shape 33"/>
           <p:cNvSpPr/>
           <p:nvPr/>
         </p:nvSpPr>
@@ -3816,14 +4050,14 @@
       </p:sp>
       <p:sp>
         <p:nvSpPr>
-          <p:cNvPr id="31" name="Text 28"/>
+          <p:cNvPr id="37" name="Text 34"/>
           <p:cNvSpPr txBox="1"/>
           <p:nvPr/>
         </p:nvSpPr>
         <p:spPr>
           <a:xfrm>
             <a:off x="1042416" y="4151376"/>
-            <a:ext cx="2084832" cy="201168"/>
+            <a:ext cx="1581912" cy="201168"/>
           </a:xfrm>
           <a:prstGeom prst="rect">
             <a:avLst/>
@@ -3855,13 +4089,13 @@
       </p:sp>
       <p:sp>
         <p:nvSpPr>
-          <p:cNvPr id="32" name="Text 29"/>
-          <p:cNvSpPr txBox="1"/>
-          <p:nvPr/>
-        </p:nvSpPr>
-        <p:spPr>
-          <a:xfrm>
-            <a:off x="3154680" y="4151376"/>
+          <p:cNvPr id="38" name="Text 35"/>
+          <p:cNvSpPr txBox="1"/>
+          <p:nvPr/>
+        </p:nvSpPr>
+        <p:spPr>
+          <a:xfrm>
+            <a:off x="2679192" y="4151376"/>
             <a:ext cx="640080" cy="201168"/>
           </a:xfrm>
           <a:prstGeom prst="rect">
@@ -3894,7 +4128,46 @@
       </p:sp>
       <p:sp>
         <p:nvSpPr>
-          <p:cNvPr id="33" name="Shape 30"/>
+          <p:cNvPr id="39" name="Text 36"/>
+          <p:cNvSpPr txBox="1"/>
+          <p:nvPr/>
+        </p:nvSpPr>
+        <p:spPr>
+          <a:xfrm>
+            <a:off x="3392424" y="4151376"/>
+            <a:ext cx="402336" cy="201168"/>
+          </a:xfrm>
+          <a:prstGeom prst="rect">
+            <a:avLst/>
+          </a:prstGeom>
+          <a:noFill/>
+          <a:ln/>
+        </p:spPr>
+        <p:txBody>
+          <a:bodyPr wrap="square" lIns="0" tIns="0" rIns="0" bIns="0" rtlCol="0" anchor="ctr"/>
+          <a:lstStyle/>
+          <a:p>
+            <a:pPr algn="r" indent="0" marL="0">
+              <a:buNone/>
+            </a:pPr>
+            <a:r>
+              <a:rPr lang="en-US" sz="900" b="1" dirty="0">
+                <a:solidFill>
+                  <a:srgbClr val="E9A13B"/>
+                </a:solidFill>
+                <a:latin typeface="Calibri" pitchFamily="34" charset="0"/>
+                <a:ea typeface="Calibri" pitchFamily="34" charset="-122"/>
+                <a:cs typeface="Calibri" pitchFamily="34" charset="-120"/>
+              </a:rPr>
+              <a:t>05/10</a:t>
+            </a:r>
+            <a:endParaRPr lang="en-US" sz="900" dirty="0"/>
+          </a:p>
+        </p:txBody>
+      </p:sp>
+      <p:sp>
+        <p:nvSpPr>
+          <p:cNvPr id="40" name="Shape 37"/>
           <p:cNvSpPr/>
           <p:nvPr/>
         </p:nvSpPr>
@@ -3916,14 +4189,14 @@
       </p:sp>
       <p:sp>
         <p:nvSpPr>
-          <p:cNvPr id="34" name="Text 31"/>
+          <p:cNvPr id="41" name="Text 38"/>
           <p:cNvSpPr txBox="1"/>
           <p:nvPr/>
         </p:nvSpPr>
         <p:spPr>
           <a:xfrm>
             <a:off x="1042416" y="4352544"/>
-            <a:ext cx="2084832" cy="201168"/>
+            <a:ext cx="1581912" cy="201168"/>
           </a:xfrm>
           <a:prstGeom prst="rect">
             <a:avLst/>
@@ -3955,13 +4228,13 @@
       </p:sp>
       <p:sp>
         <p:nvSpPr>
-          <p:cNvPr id="35" name="Text 32"/>
-          <p:cNvSpPr txBox="1"/>
-          <p:nvPr/>
-        </p:nvSpPr>
-        <p:spPr>
-          <a:xfrm>
-            <a:off x="3154680" y="4352544"/>
+          <p:cNvPr id="42" name="Text 39"/>
+          <p:cNvSpPr txBox="1"/>
+          <p:nvPr/>
+        </p:nvSpPr>
+        <p:spPr>
+          <a:xfrm>
+            <a:off x="2679192" y="4352544"/>
             <a:ext cx="640080" cy="201168"/>
           </a:xfrm>
           <a:prstGeom prst="rect">
@@ -3994,14 +4267,53 @@
       </p:sp>
       <p:sp>
         <p:nvSpPr>
-          <p:cNvPr id="36" name="Text 33"/>
+          <p:cNvPr id="43" name="Text 40"/>
+          <p:cNvSpPr txBox="1"/>
+          <p:nvPr/>
+        </p:nvSpPr>
+        <p:spPr>
+          <a:xfrm>
+            <a:off x="3392424" y="4352544"/>
+            <a:ext cx="402336" cy="201168"/>
+          </a:xfrm>
+          <a:prstGeom prst="rect">
+            <a:avLst/>
+          </a:prstGeom>
+          <a:noFill/>
+          <a:ln/>
+        </p:spPr>
+        <p:txBody>
+          <a:bodyPr wrap="square" lIns="0" tIns="0" rIns="0" bIns="0" rtlCol="0" anchor="ctr"/>
+          <a:lstStyle/>
+          <a:p>
+            <a:pPr algn="r" indent="0" marL="0">
+              <a:buNone/>
+            </a:pPr>
+            <a:r>
+              <a:rPr lang="en-US" sz="900" b="1" dirty="0">
+                <a:solidFill>
+                  <a:srgbClr val="E9A13B"/>
+                </a:solidFill>
+                <a:latin typeface="Calibri" pitchFamily="34" charset="0"/>
+                <a:ea typeface="Calibri" pitchFamily="34" charset="-122"/>
+                <a:cs typeface="Calibri" pitchFamily="34" charset="-120"/>
+              </a:rPr>
+              <a:t>05/10</a:t>
+            </a:r>
+            <a:endParaRPr lang="en-US" sz="900" dirty="0"/>
+          </a:p>
+        </p:txBody>
+      </p:sp>
+      <p:sp>
+        <p:nvSpPr>
+          <p:cNvPr id="44" name="Text 41"/>
           <p:cNvSpPr txBox="1"/>
           <p:nvPr/>
         </p:nvSpPr>
         <p:spPr>
           <a:xfrm>
             <a:off x="841248" y="4590288"/>
-            <a:ext cx="2953512" cy="201168"/>
+            <a:ext cx="1947672" cy="201168"/>
           </a:xfrm>
           <a:prstGeom prst="rect">
             <a:avLst/>
@@ -4033,7 +4345,7 @@
       </p:sp>
       <p:sp>
         <p:nvSpPr>
-          <p:cNvPr id="37" name="Shape 34"/>
+          <p:cNvPr id="45" name="Shape 42"/>
           <p:cNvSpPr/>
           <p:nvPr/>
         </p:nvSpPr>
@@ -4055,14 +4367,14 @@
       </p:sp>
       <p:sp>
         <p:nvSpPr>
-          <p:cNvPr id="38" name="Text 35"/>
+          <p:cNvPr id="46" name="Text 43"/>
           <p:cNvSpPr txBox="1"/>
           <p:nvPr/>
         </p:nvSpPr>
         <p:spPr>
           <a:xfrm>
             <a:off x="1042416" y="4809744"/>
-            <a:ext cx="2084832" cy="201168"/>
+            <a:ext cx="1581912" cy="201168"/>
           </a:xfrm>
           <a:prstGeom prst="rect">
             <a:avLst/>
@@ -4094,13 +4406,13 @@
       </p:sp>
       <p:sp>
         <p:nvSpPr>
-          <p:cNvPr id="39" name="Text 36"/>
-          <p:cNvSpPr txBox="1"/>
-          <p:nvPr/>
-        </p:nvSpPr>
-        <p:spPr>
-          <a:xfrm>
-            <a:off x="3154680" y="4809744"/>
+          <p:cNvPr id="47" name="Text 44"/>
+          <p:cNvSpPr txBox="1"/>
+          <p:nvPr/>
+        </p:nvSpPr>
+        <p:spPr>
+          <a:xfrm>
+            <a:off x="2679192" y="4809744"/>
             <a:ext cx="640080" cy="201168"/>
           </a:xfrm>
           <a:prstGeom prst="rect">
@@ -4133,7 +4445,46 @@
       </p:sp>
       <p:sp>
         <p:nvSpPr>
-          <p:cNvPr id="40" name="Shape 37"/>
+          <p:cNvPr id="48" name="Text 45"/>
+          <p:cNvSpPr txBox="1"/>
+          <p:nvPr/>
+        </p:nvSpPr>
+        <p:spPr>
+          <a:xfrm>
+            <a:off x="3392424" y="4809744"/>
+            <a:ext cx="402336" cy="201168"/>
+          </a:xfrm>
+          <a:prstGeom prst="rect">
+            <a:avLst/>
+          </a:prstGeom>
+          <a:noFill/>
+          <a:ln/>
+        </p:spPr>
+        <p:txBody>
+          <a:bodyPr wrap="square" lIns="0" tIns="0" rIns="0" bIns="0" rtlCol="0" anchor="ctr"/>
+          <a:lstStyle/>
+          <a:p>
+            <a:pPr algn="r" indent="0" marL="0">
+              <a:buNone/>
+            </a:pPr>
+            <a:r>
+              <a:rPr lang="en-US" sz="900" b="1" dirty="0">
+                <a:solidFill>
+                  <a:srgbClr val="E9A13B"/>
+                </a:solidFill>
+                <a:latin typeface="Calibri" pitchFamily="34" charset="0"/>
+                <a:ea typeface="Calibri" pitchFamily="34" charset="-122"/>
+                <a:cs typeface="Calibri" pitchFamily="34" charset="-120"/>
+              </a:rPr>
+              <a:t>10/10</a:t>
+            </a:r>
+            <a:endParaRPr lang="en-US" sz="900" dirty="0"/>
+          </a:p>
+        </p:txBody>
+      </p:sp>
+      <p:sp>
+        <p:nvSpPr>
+          <p:cNvPr id="49" name="Shape 46"/>
           <p:cNvSpPr/>
           <p:nvPr/>
         </p:nvSpPr>
@@ -4155,14 +4506,14 @@
       </p:sp>
       <p:sp>
         <p:nvSpPr>
-          <p:cNvPr id="41" name="Text 38"/>
+          <p:cNvPr id="50" name="Text 47"/>
           <p:cNvSpPr txBox="1"/>
           <p:nvPr/>
         </p:nvSpPr>
         <p:spPr>
           <a:xfrm>
             <a:off x="1042416" y="5010912"/>
-            <a:ext cx="2084832" cy="201168"/>
+            <a:ext cx="1581912" cy="201168"/>
           </a:xfrm>
           <a:prstGeom prst="rect">
             <a:avLst/>
@@ -4194,13 +4545,13 @@
       </p:sp>
       <p:sp>
         <p:nvSpPr>
-          <p:cNvPr id="42" name="Text 39"/>
-          <p:cNvSpPr txBox="1"/>
-          <p:nvPr/>
-        </p:nvSpPr>
-        <p:spPr>
-          <a:xfrm>
-            <a:off x="3154680" y="5010912"/>
+          <p:cNvPr id="51" name="Text 48"/>
+          <p:cNvSpPr txBox="1"/>
+          <p:nvPr/>
+        </p:nvSpPr>
+        <p:spPr>
+          <a:xfrm>
+            <a:off x="2679192" y="5010912"/>
             <a:ext cx="640080" cy="201168"/>
           </a:xfrm>
           <a:prstGeom prst="rect">
@@ -4233,7 +4584,46 @@
       </p:sp>
       <p:sp>
         <p:nvSpPr>
-          <p:cNvPr id="43" name="Shape 40"/>
+          <p:cNvPr id="52" name="Text 49"/>
+          <p:cNvSpPr txBox="1"/>
+          <p:nvPr/>
+        </p:nvSpPr>
+        <p:spPr>
+          <a:xfrm>
+            <a:off x="3392424" y="5010912"/>
+            <a:ext cx="402336" cy="201168"/>
+          </a:xfrm>
+          <a:prstGeom prst="rect">
+            <a:avLst/>
+          </a:prstGeom>
+          <a:noFill/>
+          <a:ln/>
+        </p:spPr>
+        <p:txBody>
+          <a:bodyPr wrap="square" lIns="0" tIns="0" rIns="0" bIns="0" rtlCol="0" anchor="ctr"/>
+          <a:lstStyle/>
+          <a:p>
+            <a:pPr algn="r" indent="0" marL="0">
+              <a:buNone/>
+            </a:pPr>
+            <a:r>
+              <a:rPr lang="en-US" sz="900" b="1" dirty="0">
+                <a:solidFill>
+                  <a:srgbClr val="E9A13B"/>
+                </a:solidFill>
+                <a:latin typeface="Calibri" pitchFamily="34" charset="0"/>
+                <a:ea typeface="Calibri" pitchFamily="34" charset="-122"/>
+                <a:cs typeface="Calibri" pitchFamily="34" charset="-120"/>
+              </a:rPr>
+              <a:t>10/10</a:t>
+            </a:r>
+            <a:endParaRPr lang="en-US" sz="900" dirty="0"/>
+          </a:p>
+        </p:txBody>
+      </p:sp>
+      <p:sp>
+        <p:nvSpPr>
+          <p:cNvPr id="53" name="Shape 50"/>
           <p:cNvSpPr/>
           <p:nvPr/>
         </p:nvSpPr>
@@ -4255,14 +4645,14 @@
       </p:sp>
       <p:sp>
         <p:nvSpPr>
-          <p:cNvPr id="44" name="Text 41"/>
+          <p:cNvPr id="54" name="Text 51"/>
           <p:cNvSpPr txBox="1"/>
           <p:nvPr/>
         </p:nvSpPr>
         <p:spPr>
           <a:xfrm>
             <a:off x="1042416" y="5212080"/>
-            <a:ext cx="2084832" cy="201168"/>
+            <a:ext cx="1581912" cy="201168"/>
           </a:xfrm>
           <a:prstGeom prst="rect">
             <a:avLst/>
@@ -4294,13 +4684,13 @@
       </p:sp>
       <p:sp>
         <p:nvSpPr>
-          <p:cNvPr id="45" name="Text 42"/>
-          <p:cNvSpPr txBox="1"/>
-          <p:nvPr/>
-        </p:nvSpPr>
-        <p:spPr>
-          <a:xfrm>
-            <a:off x="3154680" y="5212080"/>
+          <p:cNvPr id="55" name="Text 52"/>
+          <p:cNvSpPr txBox="1"/>
+          <p:nvPr/>
+        </p:nvSpPr>
+        <p:spPr>
+          <a:xfrm>
+            <a:off x="2679192" y="5212080"/>
             <a:ext cx="640080" cy="201168"/>
           </a:xfrm>
           <a:prstGeom prst="rect">
@@ -4333,7 +4723,46 @@
       </p:sp>
       <p:sp>
         <p:nvSpPr>
-          <p:cNvPr id="46" name="Shape 43"/>
+          <p:cNvPr id="56" name="Text 53"/>
+          <p:cNvSpPr txBox="1"/>
+          <p:nvPr/>
+        </p:nvSpPr>
+        <p:spPr>
+          <a:xfrm>
+            <a:off x="3392424" y="5212080"/>
+            <a:ext cx="402336" cy="201168"/>
+          </a:xfrm>
+          <a:prstGeom prst="rect">
+            <a:avLst/>
+          </a:prstGeom>
+          <a:noFill/>
+          <a:ln/>
+        </p:spPr>
+        <p:txBody>
+          <a:bodyPr wrap="square" lIns="0" tIns="0" rIns="0" bIns="0" rtlCol="0" anchor="ctr"/>
+          <a:lstStyle/>
+          <a:p>
+            <a:pPr algn="r" indent="0" marL="0">
+              <a:buNone/>
+            </a:pPr>
+            <a:r>
+              <a:rPr lang="en-US" sz="900" b="1" dirty="0">
+                <a:solidFill>
+                  <a:srgbClr val="E9A13B"/>
+                </a:solidFill>
+                <a:latin typeface="Calibri" pitchFamily="34" charset="0"/>
+                <a:ea typeface="Calibri" pitchFamily="34" charset="-122"/>
+                <a:cs typeface="Calibri" pitchFamily="34" charset="-120"/>
+              </a:rPr>
+              <a:t>10/10</a:t>
+            </a:r>
+            <a:endParaRPr lang="en-US" sz="900" dirty="0"/>
+          </a:p>
+        </p:txBody>
+      </p:sp>
+      <p:sp>
+        <p:nvSpPr>
+          <p:cNvPr id="57" name="Shape 54"/>
           <p:cNvSpPr/>
           <p:nvPr/>
         </p:nvSpPr>
@@ -4362,7 +4791,7 @@
       </p:sp>
       <p:sp>
         <p:nvSpPr>
-          <p:cNvPr id="47" name="Text 44"/>
+          <p:cNvPr id="58" name="Text 55"/>
           <p:cNvSpPr txBox="1"/>
           <p:nvPr/>
         </p:nvSpPr>
@@ -4401,7 +4830,7 @@
       </p:sp>
       <p:sp>
         <p:nvSpPr>
-          <p:cNvPr id="48" name="Text 45"/>
+          <p:cNvPr id="59" name="Text 56"/>
           <p:cNvSpPr txBox="1"/>
           <p:nvPr/>
         </p:nvSpPr>
@@ -4440,7 +4869,7 @@
       </p:sp>
       <p:sp>
         <p:nvSpPr>
-          <p:cNvPr id="49" name="Text 46"/>
+          <p:cNvPr id="60" name="Text 57"/>
           <p:cNvSpPr txBox="1"/>
           <p:nvPr/>
         </p:nvSpPr>
@@ -4471,7 +4900,7 @@
                 <a:ea typeface="Calibri" pitchFamily="34" charset="-122"/>
                 <a:cs typeface="Calibri" pitchFamily="34" charset="-120"/>
               </a:rPr>
-              <a:t>Periodicidade a definir  ·  prazos 05 e 08/10</a:t>
+              <a:t>Periodicidade a definir</a:t>
             </a:r>
             <a:endParaRPr lang="en-US" sz="900" dirty="0"/>
           </a:p>
@@ -4479,7 +4908,7 @@
       </p:sp>
       <p:sp>
         <p:nvSpPr>
-          <p:cNvPr id="50" name="Shape 47"/>
+          <p:cNvPr id="61" name="Shape 58"/>
           <p:cNvSpPr/>
           <p:nvPr/>
         </p:nvSpPr>
@@ -4510,7 +4939,7 @@
       </p:sp>
       <p:sp>
         <p:nvSpPr>
-          <p:cNvPr id="51" name="Shape 48"/>
+          <p:cNvPr id="62" name="Shape 59"/>
           <p:cNvSpPr/>
           <p:nvPr/>
         </p:nvSpPr>
@@ -4532,14 +4961,14 @@
       </p:sp>
       <p:sp>
         <p:nvSpPr>
-          <p:cNvPr id="52" name="Text 49"/>
+          <p:cNvPr id="63" name="Text 60"/>
           <p:cNvSpPr txBox="1"/>
           <p:nvPr/>
         </p:nvSpPr>
         <p:spPr>
           <a:xfrm>
             <a:off x="4617720" y="2871216"/>
-            <a:ext cx="2953512" cy="201168"/>
+            <a:ext cx="1947672" cy="201168"/>
           </a:xfrm>
           <a:prstGeom prst="rect">
             <a:avLst/>
@@ -4571,7 +5000,85 @@
       </p:sp>
       <p:sp>
         <p:nvSpPr>
-          <p:cNvPr id="53" name="Shape 50"/>
+          <p:cNvPr id="64" name="Text 61"/>
+          <p:cNvSpPr txBox="1"/>
+          <p:nvPr/>
+        </p:nvSpPr>
+        <p:spPr>
+          <a:xfrm>
+            <a:off x="6455664" y="2871216"/>
+            <a:ext cx="640080" cy="201168"/>
+          </a:xfrm>
+          <a:prstGeom prst="rect">
+            <a:avLst/>
+          </a:prstGeom>
+          <a:noFill/>
+          <a:ln/>
+        </p:spPr>
+        <p:txBody>
+          <a:bodyPr wrap="square" lIns="0" tIns="0" rIns="0" bIns="0" rtlCol="0" anchor="ctr"/>
+          <a:lstStyle/>
+          <a:p>
+            <a:pPr algn="r" indent="0" marL="0">
+              <a:buNone/>
+            </a:pPr>
+            <a:r>
+              <a:rPr lang="en-US" sz="700" b="1" spc="80" kern="0" dirty="0">
+                <a:solidFill>
+                  <a:srgbClr val="93A9C6"/>
+                </a:solidFill>
+                <a:latin typeface="Calibri" pitchFamily="34" charset="0"/>
+                <a:ea typeface="Calibri" pitchFamily="34" charset="-122"/>
+                <a:cs typeface="Calibri" pitchFamily="34" charset="-120"/>
+              </a:rPr>
+              <a:t>FOCAL</a:t>
+            </a:r>
+            <a:endParaRPr lang="en-US" sz="700" dirty="0"/>
+          </a:p>
+        </p:txBody>
+      </p:sp>
+      <p:sp>
+        <p:nvSpPr>
+          <p:cNvPr id="65" name="Text 62"/>
+          <p:cNvSpPr txBox="1"/>
+          <p:nvPr/>
+        </p:nvSpPr>
+        <p:spPr>
+          <a:xfrm>
+            <a:off x="7168896" y="2871216"/>
+            <a:ext cx="402336" cy="201168"/>
+          </a:xfrm>
+          <a:prstGeom prst="rect">
+            <a:avLst/>
+          </a:prstGeom>
+          <a:noFill/>
+          <a:ln/>
+        </p:spPr>
+        <p:txBody>
+          <a:bodyPr wrap="square" lIns="0" tIns="0" rIns="0" bIns="0" rtlCol="0" anchor="ctr"/>
+          <a:lstStyle/>
+          <a:p>
+            <a:pPr algn="r" indent="0" marL="0">
+              <a:buNone/>
+            </a:pPr>
+            <a:r>
+              <a:rPr lang="en-US" sz="700" b="1" spc="80" kern="0" dirty="0">
+                <a:solidFill>
+                  <a:srgbClr val="93A9C6"/>
+                </a:solidFill>
+                <a:latin typeface="Calibri" pitchFamily="34" charset="0"/>
+                <a:ea typeface="Calibri" pitchFamily="34" charset="-122"/>
+                <a:cs typeface="Calibri" pitchFamily="34" charset="-120"/>
+              </a:rPr>
+              <a:t>PRAZO</a:t>
+            </a:r>
+            <a:endParaRPr lang="en-US" sz="700" dirty="0"/>
+          </a:p>
+        </p:txBody>
+      </p:sp>
+      <p:sp>
+        <p:nvSpPr>
+          <p:cNvPr id="66" name="Shape 63"/>
           <p:cNvSpPr/>
           <p:nvPr/>
         </p:nvSpPr>
@@ -4593,14 +5100,14 @@
       </p:sp>
       <p:sp>
         <p:nvSpPr>
-          <p:cNvPr id="54" name="Text 51"/>
+          <p:cNvPr id="67" name="Text 64"/>
           <p:cNvSpPr txBox="1"/>
           <p:nvPr/>
         </p:nvSpPr>
         <p:spPr>
           <a:xfrm>
             <a:off x="4818888" y="3090672"/>
-            <a:ext cx="2084832" cy="201168"/>
+            <a:ext cx="1581912" cy="201168"/>
           </a:xfrm>
           <a:prstGeom prst="rect">
             <a:avLst/>
@@ -4632,13 +5139,13 @@
       </p:sp>
       <p:sp>
         <p:nvSpPr>
-          <p:cNvPr id="55" name="Text 52"/>
-          <p:cNvSpPr txBox="1"/>
-          <p:nvPr/>
-        </p:nvSpPr>
-        <p:spPr>
-          <a:xfrm>
-            <a:off x="6931152" y="3090672"/>
+          <p:cNvPr id="68" name="Text 65"/>
+          <p:cNvSpPr txBox="1"/>
+          <p:nvPr/>
+        </p:nvSpPr>
+        <p:spPr>
+          <a:xfrm>
+            <a:off x="6455664" y="3090672"/>
             <a:ext cx="640080" cy="201168"/>
           </a:xfrm>
           <a:prstGeom prst="rect">
@@ -4671,7 +5178,46 @@
       </p:sp>
       <p:sp>
         <p:nvSpPr>
-          <p:cNvPr id="56" name="Shape 53"/>
+          <p:cNvPr id="69" name="Text 66"/>
+          <p:cNvSpPr txBox="1"/>
+          <p:nvPr/>
+        </p:nvSpPr>
+        <p:spPr>
+          <a:xfrm>
+            <a:off x="7168896" y="3090672"/>
+            <a:ext cx="402336" cy="201168"/>
+          </a:xfrm>
+          <a:prstGeom prst="rect">
+            <a:avLst/>
+          </a:prstGeom>
+          <a:noFill/>
+          <a:ln/>
+        </p:spPr>
+        <p:txBody>
+          <a:bodyPr wrap="square" lIns="0" tIns="0" rIns="0" bIns="0" rtlCol="0" anchor="ctr"/>
+          <a:lstStyle/>
+          <a:p>
+            <a:pPr algn="r" indent="0" marL="0">
+              <a:buNone/>
+            </a:pPr>
+            <a:r>
+              <a:rPr lang="en-US" sz="900" b="1" dirty="0">
+                <a:solidFill>
+                  <a:srgbClr val="E9A13B"/>
+                </a:solidFill>
+                <a:latin typeface="Calibri" pitchFamily="34" charset="0"/>
+                <a:ea typeface="Calibri" pitchFamily="34" charset="-122"/>
+                <a:cs typeface="Calibri" pitchFamily="34" charset="-120"/>
+              </a:rPr>
+              <a:t>05/10</a:t>
+            </a:r>
+            <a:endParaRPr lang="en-US" sz="900" dirty="0"/>
+          </a:p>
+        </p:txBody>
+      </p:sp>
+      <p:sp>
+        <p:nvSpPr>
+          <p:cNvPr id="70" name="Shape 67"/>
           <p:cNvSpPr/>
           <p:nvPr/>
         </p:nvSpPr>
@@ -4691,14 +5237,14 @@
       </p:sp>
       <p:sp>
         <p:nvSpPr>
-          <p:cNvPr id="57" name="Text 54"/>
+          <p:cNvPr id="71" name="Text 68"/>
           <p:cNvSpPr txBox="1"/>
           <p:nvPr/>
         </p:nvSpPr>
         <p:spPr>
           <a:xfrm>
             <a:off x="4818888" y="3291840"/>
-            <a:ext cx="2084832" cy="201168"/>
+            <a:ext cx="1581912" cy="201168"/>
           </a:xfrm>
           <a:prstGeom prst="rect">
             <a:avLst/>
@@ -4730,13 +5276,13 @@
       </p:sp>
       <p:sp>
         <p:nvSpPr>
-          <p:cNvPr id="58" name="Text 55"/>
-          <p:cNvSpPr txBox="1"/>
-          <p:nvPr/>
-        </p:nvSpPr>
-        <p:spPr>
-          <a:xfrm>
-            <a:off x="6931152" y="3291840"/>
+          <p:cNvPr id="72" name="Text 69"/>
+          <p:cNvSpPr txBox="1"/>
+          <p:nvPr/>
+        </p:nvSpPr>
+        <p:spPr>
+          <a:xfrm>
+            <a:off x="6455664" y="3291840"/>
             <a:ext cx="640080" cy="201168"/>
           </a:xfrm>
           <a:prstGeom prst="rect">
@@ -4769,7 +5315,46 @@
       </p:sp>
       <p:sp>
         <p:nvSpPr>
-          <p:cNvPr id="59" name="Shape 56"/>
+          <p:cNvPr id="73" name="Text 70"/>
+          <p:cNvSpPr txBox="1"/>
+          <p:nvPr/>
+        </p:nvSpPr>
+        <p:spPr>
+          <a:xfrm>
+            <a:off x="7168896" y="3291840"/>
+            <a:ext cx="402336" cy="201168"/>
+          </a:xfrm>
+          <a:prstGeom prst="rect">
+            <a:avLst/>
+          </a:prstGeom>
+          <a:noFill/>
+          <a:ln/>
+        </p:spPr>
+        <p:txBody>
+          <a:bodyPr wrap="square" lIns="0" tIns="0" rIns="0" bIns="0" rtlCol="0" anchor="ctr"/>
+          <a:lstStyle/>
+          <a:p>
+            <a:pPr algn="r" indent="0" marL="0">
+              <a:buNone/>
+            </a:pPr>
+            <a:r>
+              <a:rPr lang="en-US" sz="900" dirty="0">
+                <a:solidFill>
+                  <a:srgbClr val="93A9C6"/>
+                </a:solidFill>
+                <a:latin typeface="Calibri" pitchFamily="34" charset="0"/>
+                <a:ea typeface="Calibri" pitchFamily="34" charset="-122"/>
+                <a:cs typeface="Calibri" pitchFamily="34" charset="-120"/>
+              </a:rPr>
+              <a:t>08/10</a:t>
+            </a:r>
+            <a:endParaRPr lang="en-US" sz="900" dirty="0"/>
+          </a:p>
+        </p:txBody>
+      </p:sp>
+      <p:sp>
+        <p:nvSpPr>
+          <p:cNvPr id="74" name="Shape 71"/>
           <p:cNvSpPr/>
           <p:nvPr/>
         </p:nvSpPr>
@@ -4789,14 +5374,14 @@
       </p:sp>
       <p:sp>
         <p:nvSpPr>
-          <p:cNvPr id="60" name="Text 57"/>
+          <p:cNvPr id="75" name="Text 72"/>
           <p:cNvSpPr txBox="1"/>
           <p:nvPr/>
         </p:nvSpPr>
         <p:spPr>
           <a:xfrm>
             <a:off x="4818888" y="3493008"/>
-            <a:ext cx="2084832" cy="201168"/>
+            <a:ext cx="1581912" cy="201168"/>
           </a:xfrm>
           <a:prstGeom prst="rect">
             <a:avLst/>
@@ -4828,13 +5413,13 @@
       </p:sp>
       <p:sp>
         <p:nvSpPr>
-          <p:cNvPr id="61" name="Text 58"/>
-          <p:cNvSpPr txBox="1"/>
-          <p:nvPr/>
-        </p:nvSpPr>
-        <p:spPr>
-          <a:xfrm>
-            <a:off x="6931152" y="3493008"/>
+          <p:cNvPr id="76" name="Text 73"/>
+          <p:cNvSpPr txBox="1"/>
+          <p:nvPr/>
+        </p:nvSpPr>
+        <p:spPr>
+          <a:xfrm>
+            <a:off x="6455664" y="3493008"/>
             <a:ext cx="640080" cy="201168"/>
           </a:xfrm>
           <a:prstGeom prst="rect">
@@ -4867,7 +5452,46 @@
       </p:sp>
       <p:sp>
         <p:nvSpPr>
-          <p:cNvPr id="62" name="Shape 59"/>
+          <p:cNvPr id="77" name="Text 74"/>
+          <p:cNvSpPr txBox="1"/>
+          <p:nvPr/>
+        </p:nvSpPr>
+        <p:spPr>
+          <a:xfrm>
+            <a:off x="7168896" y="3493008"/>
+            <a:ext cx="402336" cy="201168"/>
+          </a:xfrm>
+          <a:prstGeom prst="rect">
+            <a:avLst/>
+          </a:prstGeom>
+          <a:noFill/>
+          <a:ln/>
+        </p:spPr>
+        <p:txBody>
+          <a:bodyPr wrap="square" lIns="0" tIns="0" rIns="0" bIns="0" rtlCol="0" anchor="ctr"/>
+          <a:lstStyle/>
+          <a:p>
+            <a:pPr algn="r" indent="0" marL="0">
+              <a:buNone/>
+            </a:pPr>
+            <a:r>
+              <a:rPr lang="en-US" sz="900" dirty="0">
+                <a:solidFill>
+                  <a:srgbClr val="93A9C6"/>
+                </a:solidFill>
+                <a:latin typeface="Calibri" pitchFamily="34" charset="0"/>
+                <a:ea typeface="Calibri" pitchFamily="34" charset="-122"/>
+                <a:cs typeface="Calibri" pitchFamily="34" charset="-120"/>
+              </a:rPr>
+              <a:t>08/10</a:t>
+            </a:r>
+            <a:endParaRPr lang="en-US" sz="900" dirty="0"/>
+          </a:p>
+        </p:txBody>
+      </p:sp>
+      <p:sp>
+        <p:nvSpPr>
+          <p:cNvPr id="78" name="Shape 75"/>
           <p:cNvSpPr/>
           <p:nvPr/>
         </p:nvSpPr>
@@ -4889,14 +5513,14 @@
       </p:sp>
       <p:sp>
         <p:nvSpPr>
-          <p:cNvPr id="63" name="Text 60"/>
+          <p:cNvPr id="79" name="Text 76"/>
           <p:cNvSpPr txBox="1"/>
           <p:nvPr/>
         </p:nvSpPr>
         <p:spPr>
           <a:xfrm>
             <a:off x="4818888" y="3694176"/>
-            <a:ext cx="2084832" cy="201168"/>
+            <a:ext cx="1581912" cy="201168"/>
           </a:xfrm>
           <a:prstGeom prst="rect">
             <a:avLst/>
@@ -4928,13 +5552,13 @@
       </p:sp>
       <p:sp>
         <p:nvSpPr>
-          <p:cNvPr id="64" name="Text 61"/>
-          <p:cNvSpPr txBox="1"/>
-          <p:nvPr/>
-        </p:nvSpPr>
-        <p:spPr>
-          <a:xfrm>
-            <a:off x="6931152" y="3694176"/>
+          <p:cNvPr id="80" name="Text 77"/>
+          <p:cNvSpPr txBox="1"/>
+          <p:nvPr/>
+        </p:nvSpPr>
+        <p:spPr>
+          <a:xfrm>
+            <a:off x="6455664" y="3694176"/>
             <a:ext cx="640080" cy="201168"/>
           </a:xfrm>
           <a:prstGeom prst="rect">
@@ -4967,14 +5591,53 @@
       </p:sp>
       <p:sp>
         <p:nvSpPr>
-          <p:cNvPr id="65" name="Text 62"/>
+          <p:cNvPr id="81" name="Text 78"/>
+          <p:cNvSpPr txBox="1"/>
+          <p:nvPr/>
+        </p:nvSpPr>
+        <p:spPr>
+          <a:xfrm>
+            <a:off x="7168896" y="3694176"/>
+            <a:ext cx="402336" cy="201168"/>
+          </a:xfrm>
+          <a:prstGeom prst="rect">
+            <a:avLst/>
+          </a:prstGeom>
+          <a:noFill/>
+          <a:ln/>
+        </p:spPr>
+        <p:txBody>
+          <a:bodyPr wrap="square" lIns="0" tIns="0" rIns="0" bIns="0" rtlCol="0" anchor="ctr"/>
+          <a:lstStyle/>
+          <a:p>
+            <a:pPr algn="r" indent="0" marL="0">
+              <a:buNone/>
+            </a:pPr>
+            <a:r>
+              <a:rPr lang="en-US" sz="900" b="1" dirty="0">
+                <a:solidFill>
+                  <a:srgbClr val="E9A13B"/>
+                </a:solidFill>
+                <a:latin typeface="Calibri" pitchFamily="34" charset="0"/>
+                <a:ea typeface="Calibri" pitchFamily="34" charset="-122"/>
+                <a:cs typeface="Calibri" pitchFamily="34" charset="-120"/>
+              </a:rPr>
+              <a:t>08/10</a:t>
+            </a:r>
+            <a:endParaRPr lang="en-US" sz="900" dirty="0"/>
+          </a:p>
+        </p:txBody>
+      </p:sp>
+      <p:sp>
+        <p:nvSpPr>
+          <p:cNvPr id="82" name="Text 79"/>
           <p:cNvSpPr txBox="1"/>
           <p:nvPr/>
         </p:nvSpPr>
         <p:spPr>
           <a:xfrm>
             <a:off x="4617720" y="3931920"/>
-            <a:ext cx="2953512" cy="201168"/>
+            <a:ext cx="1947672" cy="201168"/>
           </a:xfrm>
           <a:prstGeom prst="rect">
             <a:avLst/>
@@ -5006,7 +5669,7 @@
       </p:sp>
       <p:sp>
         <p:nvSpPr>
-          <p:cNvPr id="66" name="Shape 63"/>
+          <p:cNvPr id="83" name="Shape 80"/>
           <p:cNvSpPr/>
           <p:nvPr/>
         </p:nvSpPr>
@@ -5028,14 +5691,14 @@
       </p:sp>
       <p:sp>
         <p:nvSpPr>
-          <p:cNvPr id="67" name="Text 64"/>
+          <p:cNvPr id="84" name="Text 81"/>
           <p:cNvSpPr txBox="1"/>
           <p:nvPr/>
         </p:nvSpPr>
         <p:spPr>
           <a:xfrm>
             <a:off x="4818888" y="4151376"/>
-            <a:ext cx="2084832" cy="201168"/>
+            <a:ext cx="1581912" cy="201168"/>
           </a:xfrm>
           <a:prstGeom prst="rect">
             <a:avLst/>
@@ -5067,13 +5730,13 @@
       </p:sp>
       <p:sp>
         <p:nvSpPr>
-          <p:cNvPr id="68" name="Text 65"/>
-          <p:cNvSpPr txBox="1"/>
-          <p:nvPr/>
-        </p:nvSpPr>
-        <p:spPr>
-          <a:xfrm>
-            <a:off x="6931152" y="4151376"/>
+          <p:cNvPr id="85" name="Text 82"/>
+          <p:cNvSpPr txBox="1"/>
+          <p:nvPr/>
+        </p:nvSpPr>
+        <p:spPr>
+          <a:xfrm>
+            <a:off x="6455664" y="4151376"/>
             <a:ext cx="640080" cy="201168"/>
           </a:xfrm>
           <a:prstGeom prst="rect">
@@ -5106,7 +5769,46 @@
       </p:sp>
       <p:sp>
         <p:nvSpPr>
-          <p:cNvPr id="69" name="Shape 66"/>
+          <p:cNvPr id="86" name="Text 83"/>
+          <p:cNvSpPr txBox="1"/>
+          <p:nvPr/>
+        </p:nvSpPr>
+        <p:spPr>
+          <a:xfrm>
+            <a:off x="7168896" y="4151376"/>
+            <a:ext cx="402336" cy="201168"/>
+          </a:xfrm>
+          <a:prstGeom prst="rect">
+            <a:avLst/>
+          </a:prstGeom>
+          <a:noFill/>
+          <a:ln/>
+        </p:spPr>
+        <p:txBody>
+          <a:bodyPr wrap="square" lIns="0" tIns="0" rIns="0" bIns="0" rtlCol="0" anchor="ctr"/>
+          <a:lstStyle/>
+          <a:p>
+            <a:pPr algn="r" indent="0" marL="0">
+              <a:buNone/>
+            </a:pPr>
+            <a:r>
+              <a:rPr lang="en-US" sz="900" b="1" dirty="0">
+                <a:solidFill>
+                  <a:srgbClr val="E9A13B"/>
+                </a:solidFill>
+                <a:latin typeface="Calibri" pitchFamily="34" charset="0"/>
+                <a:ea typeface="Calibri" pitchFamily="34" charset="-122"/>
+                <a:cs typeface="Calibri" pitchFamily="34" charset="-120"/>
+              </a:rPr>
+              <a:t>05/10</a:t>
+            </a:r>
+            <a:endParaRPr lang="en-US" sz="900" dirty="0"/>
+          </a:p>
+        </p:txBody>
+      </p:sp>
+      <p:sp>
+        <p:nvSpPr>
+          <p:cNvPr id="87" name="Shape 84"/>
           <p:cNvSpPr/>
           <p:nvPr/>
         </p:nvSpPr>
@@ -5128,14 +5830,14 @@
       </p:sp>
       <p:sp>
         <p:nvSpPr>
-          <p:cNvPr id="70" name="Text 67"/>
+          <p:cNvPr id="88" name="Text 85"/>
           <p:cNvSpPr txBox="1"/>
           <p:nvPr/>
         </p:nvSpPr>
         <p:spPr>
           <a:xfrm>
             <a:off x="4818888" y="4352544"/>
-            <a:ext cx="2084832" cy="201168"/>
+            <a:ext cx="1581912" cy="201168"/>
           </a:xfrm>
           <a:prstGeom prst="rect">
             <a:avLst/>
@@ -5167,13 +5869,13 @@
       </p:sp>
       <p:sp>
         <p:nvSpPr>
-          <p:cNvPr id="71" name="Text 68"/>
-          <p:cNvSpPr txBox="1"/>
-          <p:nvPr/>
-        </p:nvSpPr>
-        <p:spPr>
-          <a:xfrm>
-            <a:off x="6931152" y="4352544"/>
+          <p:cNvPr id="89" name="Text 86"/>
+          <p:cNvSpPr txBox="1"/>
+          <p:nvPr/>
+        </p:nvSpPr>
+        <p:spPr>
+          <a:xfrm>
+            <a:off x="6455664" y="4352544"/>
             <a:ext cx="640080" cy="201168"/>
           </a:xfrm>
           <a:prstGeom prst="rect">
@@ -5206,14 +5908,53 @@
       </p:sp>
       <p:sp>
         <p:nvSpPr>
-          <p:cNvPr id="72" name="Text 69"/>
+          <p:cNvPr id="90" name="Text 87"/>
+          <p:cNvSpPr txBox="1"/>
+          <p:nvPr/>
+        </p:nvSpPr>
+        <p:spPr>
+          <a:xfrm>
+            <a:off x="7168896" y="4352544"/>
+            <a:ext cx="402336" cy="201168"/>
+          </a:xfrm>
+          <a:prstGeom prst="rect">
+            <a:avLst/>
+          </a:prstGeom>
+          <a:noFill/>
+          <a:ln/>
+        </p:spPr>
+        <p:txBody>
+          <a:bodyPr wrap="square" lIns="0" tIns="0" rIns="0" bIns="0" rtlCol="0" anchor="ctr"/>
+          <a:lstStyle/>
+          <a:p>
+            <a:pPr algn="r" indent="0" marL="0">
+              <a:buNone/>
+            </a:pPr>
+            <a:r>
+              <a:rPr lang="en-US" sz="900" b="1" dirty="0">
+                <a:solidFill>
+                  <a:srgbClr val="E9A13B"/>
+                </a:solidFill>
+                <a:latin typeface="Calibri" pitchFamily="34" charset="0"/>
+                <a:ea typeface="Calibri" pitchFamily="34" charset="-122"/>
+                <a:cs typeface="Calibri" pitchFamily="34" charset="-120"/>
+              </a:rPr>
+              <a:t>05/10</a:t>
+            </a:r>
+            <a:endParaRPr lang="en-US" sz="900" dirty="0"/>
+          </a:p>
+        </p:txBody>
+      </p:sp>
+      <p:sp>
+        <p:nvSpPr>
+          <p:cNvPr id="91" name="Text 88"/>
           <p:cNvSpPr txBox="1"/>
           <p:nvPr/>
         </p:nvSpPr>
         <p:spPr>
           <a:xfrm>
             <a:off x="4617720" y="4590288"/>
-            <a:ext cx="2953512" cy="201168"/>
+            <a:ext cx="1947672" cy="201168"/>
           </a:xfrm>
           <a:prstGeom prst="rect">
             <a:avLst/>
@@ -5245,7 +5986,7 @@
       </p:sp>
       <p:sp>
         <p:nvSpPr>
-          <p:cNvPr id="73" name="Shape 70"/>
+          <p:cNvPr id="92" name="Shape 89"/>
           <p:cNvSpPr/>
           <p:nvPr/>
         </p:nvSpPr>
@@ -5267,14 +6008,14 @@
       </p:sp>
       <p:sp>
         <p:nvSpPr>
-          <p:cNvPr id="74" name="Text 71"/>
+          <p:cNvPr id="93" name="Text 90"/>
           <p:cNvSpPr txBox="1"/>
           <p:nvPr/>
         </p:nvSpPr>
         <p:spPr>
           <a:xfrm>
             <a:off x="4818888" y="4809744"/>
-            <a:ext cx="2084832" cy="201168"/>
+            <a:ext cx="1581912" cy="201168"/>
           </a:xfrm>
           <a:prstGeom prst="rect">
             <a:avLst/>
@@ -5306,13 +6047,13 @@
       </p:sp>
       <p:sp>
         <p:nvSpPr>
-          <p:cNvPr id="75" name="Text 72"/>
-          <p:cNvSpPr txBox="1"/>
-          <p:nvPr/>
-        </p:nvSpPr>
-        <p:spPr>
-          <a:xfrm>
-            <a:off x="6931152" y="4809744"/>
+          <p:cNvPr id="94" name="Text 91"/>
+          <p:cNvSpPr txBox="1"/>
+          <p:nvPr/>
+        </p:nvSpPr>
+        <p:spPr>
+          <a:xfrm>
+            <a:off x="6455664" y="4809744"/>
             <a:ext cx="640080" cy="201168"/>
           </a:xfrm>
           <a:prstGeom prst="rect">
@@ -5345,7 +6086,46 @@
       </p:sp>
       <p:sp>
         <p:nvSpPr>
-          <p:cNvPr id="76" name="Shape 73"/>
+          <p:cNvPr id="95" name="Text 92"/>
+          <p:cNvSpPr txBox="1"/>
+          <p:nvPr/>
+        </p:nvSpPr>
+        <p:spPr>
+          <a:xfrm>
+            <a:off x="7168896" y="4809744"/>
+            <a:ext cx="402336" cy="201168"/>
+          </a:xfrm>
+          <a:prstGeom prst="rect">
+            <a:avLst/>
+          </a:prstGeom>
+          <a:noFill/>
+          <a:ln/>
+        </p:spPr>
+        <p:txBody>
+          <a:bodyPr wrap="square" lIns="0" tIns="0" rIns="0" bIns="0" rtlCol="0" anchor="ctr"/>
+          <a:lstStyle/>
+          <a:p>
+            <a:pPr algn="r" indent="0" marL="0">
+              <a:buNone/>
+            </a:pPr>
+            <a:r>
+              <a:rPr lang="en-US" sz="900" b="1" dirty="0">
+                <a:solidFill>
+                  <a:srgbClr val="E9A13B"/>
+                </a:solidFill>
+                <a:latin typeface="Calibri" pitchFamily="34" charset="0"/>
+                <a:ea typeface="Calibri" pitchFamily="34" charset="-122"/>
+                <a:cs typeface="Calibri" pitchFamily="34" charset="-120"/>
+              </a:rPr>
+              <a:t>08/10</a:t>
+            </a:r>
+            <a:endParaRPr lang="en-US" sz="900" dirty="0"/>
+          </a:p>
+        </p:txBody>
+      </p:sp>
+      <p:sp>
+        <p:nvSpPr>
+          <p:cNvPr id="96" name="Shape 93"/>
           <p:cNvSpPr/>
           <p:nvPr/>
         </p:nvSpPr>
@@ -5367,14 +6147,14 @@
       </p:sp>
       <p:sp>
         <p:nvSpPr>
-          <p:cNvPr id="77" name="Text 74"/>
+          <p:cNvPr id="97" name="Text 94"/>
           <p:cNvSpPr txBox="1"/>
           <p:nvPr/>
         </p:nvSpPr>
         <p:spPr>
           <a:xfrm>
             <a:off x="4818888" y="5010912"/>
-            <a:ext cx="2084832" cy="201168"/>
+            <a:ext cx="1581912" cy="201168"/>
           </a:xfrm>
           <a:prstGeom prst="rect">
             <a:avLst/>
@@ -5406,13 +6186,13 @@
       </p:sp>
       <p:sp>
         <p:nvSpPr>
-          <p:cNvPr id="78" name="Text 75"/>
-          <p:cNvSpPr txBox="1"/>
-          <p:nvPr/>
-        </p:nvSpPr>
-        <p:spPr>
-          <a:xfrm>
-            <a:off x="6931152" y="5010912"/>
+          <p:cNvPr id="98" name="Text 95"/>
+          <p:cNvSpPr txBox="1"/>
+          <p:nvPr/>
+        </p:nvSpPr>
+        <p:spPr>
+          <a:xfrm>
+            <a:off x="6455664" y="5010912"/>
             <a:ext cx="640080" cy="201168"/>
           </a:xfrm>
           <a:prstGeom prst="rect">
@@ -5445,7 +6225,46 @@
       </p:sp>
       <p:sp>
         <p:nvSpPr>
-          <p:cNvPr id="79" name="Shape 76"/>
+          <p:cNvPr id="99" name="Text 96"/>
+          <p:cNvSpPr txBox="1"/>
+          <p:nvPr/>
+        </p:nvSpPr>
+        <p:spPr>
+          <a:xfrm>
+            <a:off x="7168896" y="5010912"/>
+            <a:ext cx="402336" cy="201168"/>
+          </a:xfrm>
+          <a:prstGeom prst="rect">
+            <a:avLst/>
+          </a:prstGeom>
+          <a:noFill/>
+          <a:ln/>
+        </p:spPr>
+        <p:txBody>
+          <a:bodyPr wrap="square" lIns="0" tIns="0" rIns="0" bIns="0" rtlCol="0" anchor="ctr"/>
+          <a:lstStyle/>
+          <a:p>
+            <a:pPr algn="r" indent="0" marL="0">
+              <a:buNone/>
+            </a:pPr>
+            <a:r>
+              <a:rPr lang="en-US" sz="900" b="1" dirty="0">
+                <a:solidFill>
+                  <a:srgbClr val="E9A13B"/>
+                </a:solidFill>
+                <a:latin typeface="Calibri" pitchFamily="34" charset="0"/>
+                <a:ea typeface="Calibri" pitchFamily="34" charset="-122"/>
+                <a:cs typeface="Calibri" pitchFamily="34" charset="-120"/>
+              </a:rPr>
+              <a:t>08/10</a:t>
+            </a:r>
+            <a:endParaRPr lang="en-US" sz="900" dirty="0"/>
+          </a:p>
+        </p:txBody>
+      </p:sp>
+      <p:sp>
+        <p:nvSpPr>
+          <p:cNvPr id="100" name="Shape 97"/>
           <p:cNvSpPr/>
           <p:nvPr/>
         </p:nvSpPr>
@@ -5467,14 +6286,14 @@
       </p:sp>
       <p:sp>
         <p:nvSpPr>
-          <p:cNvPr id="80" name="Text 77"/>
+          <p:cNvPr id="101" name="Text 98"/>
           <p:cNvSpPr txBox="1"/>
           <p:nvPr/>
         </p:nvSpPr>
         <p:spPr>
           <a:xfrm>
             <a:off x="4818888" y="5212080"/>
-            <a:ext cx="2084832" cy="201168"/>
+            <a:ext cx="1581912" cy="201168"/>
           </a:xfrm>
           <a:prstGeom prst="rect">
             <a:avLst/>
@@ -5506,13 +6325,13 @@
       </p:sp>
       <p:sp>
         <p:nvSpPr>
-          <p:cNvPr id="81" name="Text 78"/>
-          <p:cNvSpPr txBox="1"/>
-          <p:nvPr/>
-        </p:nvSpPr>
-        <p:spPr>
-          <a:xfrm>
-            <a:off x="6931152" y="5212080"/>
+          <p:cNvPr id="102" name="Text 99"/>
+          <p:cNvSpPr txBox="1"/>
+          <p:nvPr/>
+        </p:nvSpPr>
+        <p:spPr>
+          <a:xfrm>
+            <a:off x="6455664" y="5212080"/>
             <a:ext cx="640080" cy="201168"/>
           </a:xfrm>
           <a:prstGeom prst="rect">
@@ -5545,7 +6364,46 @@
       </p:sp>
       <p:sp>
         <p:nvSpPr>
-          <p:cNvPr id="82" name="Shape 79"/>
+          <p:cNvPr id="103" name="Text 100"/>
+          <p:cNvSpPr txBox="1"/>
+          <p:nvPr/>
+        </p:nvSpPr>
+        <p:spPr>
+          <a:xfrm>
+            <a:off x="7168896" y="5212080"/>
+            <a:ext cx="402336" cy="201168"/>
+          </a:xfrm>
+          <a:prstGeom prst="rect">
+            <a:avLst/>
+          </a:prstGeom>
+          <a:noFill/>
+          <a:ln/>
+        </p:spPr>
+        <p:txBody>
+          <a:bodyPr wrap="square" lIns="0" tIns="0" rIns="0" bIns="0" rtlCol="0" anchor="ctr"/>
+          <a:lstStyle/>
+          <a:p>
+            <a:pPr algn="r" indent="0" marL="0">
+              <a:buNone/>
+            </a:pPr>
+            <a:r>
+              <a:rPr lang="en-US" sz="900" b="1" dirty="0">
+                <a:solidFill>
+                  <a:srgbClr val="E9A13B"/>
+                </a:solidFill>
+                <a:latin typeface="Calibri" pitchFamily="34" charset="0"/>
+                <a:ea typeface="Calibri" pitchFamily="34" charset="-122"/>
+                <a:cs typeface="Calibri" pitchFamily="34" charset="-120"/>
+              </a:rPr>
+              <a:t>08/10</a:t>
+            </a:r>
+            <a:endParaRPr lang="en-US" sz="900" dirty="0"/>
+          </a:p>
+        </p:txBody>
+      </p:sp>
+      <p:sp>
+        <p:nvSpPr>
+          <p:cNvPr id="104" name="Shape 101"/>
           <p:cNvSpPr/>
           <p:nvPr/>
         </p:nvSpPr>
@@ -5574,7 +6432,7 @@
       </p:sp>
       <p:sp>
         <p:nvSpPr>
-          <p:cNvPr id="83" name="Text 80"/>
+          <p:cNvPr id="105" name="Text 102"/>
           <p:cNvSpPr txBox="1"/>
           <p:nvPr/>
         </p:nvSpPr>
@@ -5613,7 +6471,7 @@
       </p:sp>
       <p:sp>
         <p:nvSpPr>
-          <p:cNvPr id="84" name="Text 81"/>
+          <p:cNvPr id="106" name="Text 103"/>
           <p:cNvSpPr txBox="1"/>
           <p:nvPr/>
         </p:nvSpPr>
@@ -5652,7 +6510,7 @@
       </p:sp>
       <p:sp>
         <p:nvSpPr>
-          <p:cNvPr id="85" name="Text 82"/>
+          <p:cNvPr id="107" name="Text 104"/>
           <p:cNvSpPr txBox="1"/>
           <p:nvPr/>
         </p:nvSpPr>
@@ -5683,7 +6541,7 @@
                 <a:ea typeface="Calibri" pitchFamily="34" charset="-122"/>
                 <a:cs typeface="Calibri" pitchFamily="34" charset="-120"/>
               </a:rPr>
-              <a:t>Diária (D-1)  ·  prazos 05 e 08/10</a:t>
+              <a:t>Diária (D-1)</a:t>
             </a:r>
             <a:endParaRPr lang="en-US" sz="900" dirty="0"/>
           </a:p>
@@ -5691,7 +6549,7 @@
       </p:sp>
       <p:sp>
         <p:nvSpPr>
-          <p:cNvPr id="86" name="Shape 83"/>
+          <p:cNvPr id="108" name="Shape 105"/>
           <p:cNvSpPr/>
           <p:nvPr/>
         </p:nvSpPr>
@@ -5722,7 +6580,7 @@
       </p:sp>
       <p:sp>
         <p:nvSpPr>
-          <p:cNvPr id="87" name="Shape 84"/>
+          <p:cNvPr id="109" name="Shape 106"/>
           <p:cNvSpPr/>
           <p:nvPr/>
         </p:nvSpPr>
@@ -5744,14 +6602,14 @@
       </p:sp>
       <p:sp>
         <p:nvSpPr>
-          <p:cNvPr id="88" name="Text 85"/>
+          <p:cNvPr id="110" name="Text 107"/>
           <p:cNvSpPr txBox="1"/>
           <p:nvPr/>
         </p:nvSpPr>
         <p:spPr>
           <a:xfrm>
             <a:off x="8394192" y="2871216"/>
-            <a:ext cx="2953512" cy="201168"/>
+            <a:ext cx="1947672" cy="201168"/>
           </a:xfrm>
           <a:prstGeom prst="rect">
             <a:avLst/>
@@ -5783,7 +6641,85 @@
       </p:sp>
       <p:sp>
         <p:nvSpPr>
-          <p:cNvPr id="89" name="Shape 86"/>
+          <p:cNvPr id="111" name="Text 108"/>
+          <p:cNvSpPr txBox="1"/>
+          <p:nvPr/>
+        </p:nvSpPr>
+        <p:spPr>
+          <a:xfrm>
+            <a:off x="10232136" y="2871216"/>
+            <a:ext cx="640080" cy="201168"/>
+          </a:xfrm>
+          <a:prstGeom prst="rect">
+            <a:avLst/>
+          </a:prstGeom>
+          <a:noFill/>
+          <a:ln/>
+        </p:spPr>
+        <p:txBody>
+          <a:bodyPr wrap="square" lIns="0" tIns="0" rIns="0" bIns="0" rtlCol="0" anchor="ctr"/>
+          <a:lstStyle/>
+          <a:p>
+            <a:pPr algn="r" indent="0" marL="0">
+              <a:buNone/>
+            </a:pPr>
+            <a:r>
+              <a:rPr lang="en-US" sz="700" b="1" spc="80" kern="0" dirty="0">
+                <a:solidFill>
+                  <a:srgbClr val="93A9C6"/>
+                </a:solidFill>
+                <a:latin typeface="Calibri" pitchFamily="34" charset="0"/>
+                <a:ea typeface="Calibri" pitchFamily="34" charset="-122"/>
+                <a:cs typeface="Calibri" pitchFamily="34" charset="-120"/>
+              </a:rPr>
+              <a:t>FOCAL</a:t>
+            </a:r>
+            <a:endParaRPr lang="en-US" sz="700" dirty="0"/>
+          </a:p>
+        </p:txBody>
+      </p:sp>
+      <p:sp>
+        <p:nvSpPr>
+          <p:cNvPr id="112" name="Text 109"/>
+          <p:cNvSpPr txBox="1"/>
+          <p:nvPr/>
+        </p:nvSpPr>
+        <p:spPr>
+          <a:xfrm>
+            <a:off x="10945368" y="2871216"/>
+            <a:ext cx="402336" cy="201168"/>
+          </a:xfrm>
+          <a:prstGeom prst="rect">
+            <a:avLst/>
+          </a:prstGeom>
+          <a:noFill/>
+          <a:ln/>
+        </p:spPr>
+        <p:txBody>
+          <a:bodyPr wrap="square" lIns="0" tIns="0" rIns="0" bIns="0" rtlCol="0" anchor="ctr"/>
+          <a:lstStyle/>
+          <a:p>
+            <a:pPr algn="r" indent="0" marL="0">
+              <a:buNone/>
+            </a:pPr>
+            <a:r>
+              <a:rPr lang="en-US" sz="700" b="1" spc="80" kern="0" dirty="0">
+                <a:solidFill>
+                  <a:srgbClr val="93A9C6"/>
+                </a:solidFill>
+                <a:latin typeface="Calibri" pitchFamily="34" charset="0"/>
+                <a:ea typeface="Calibri" pitchFamily="34" charset="-122"/>
+                <a:cs typeface="Calibri" pitchFamily="34" charset="-120"/>
+              </a:rPr>
+              <a:t>PRAZO</a:t>
+            </a:r>
+            <a:endParaRPr lang="en-US" sz="700" dirty="0"/>
+          </a:p>
+        </p:txBody>
+      </p:sp>
+      <p:sp>
+        <p:nvSpPr>
+          <p:cNvPr id="113" name="Shape 110"/>
           <p:cNvSpPr/>
           <p:nvPr/>
         </p:nvSpPr>
@@ -5805,14 +6741,14 @@
       </p:sp>
       <p:sp>
         <p:nvSpPr>
-          <p:cNvPr id="90" name="Text 87"/>
+          <p:cNvPr id="114" name="Text 111"/>
           <p:cNvSpPr txBox="1"/>
           <p:nvPr/>
         </p:nvSpPr>
         <p:spPr>
           <a:xfrm>
             <a:off x="8595360" y="3090672"/>
-            <a:ext cx="2084832" cy="201168"/>
+            <a:ext cx="1581912" cy="201168"/>
           </a:xfrm>
           <a:prstGeom prst="rect">
             <a:avLst/>
@@ -5844,13 +6780,13 @@
       </p:sp>
       <p:sp>
         <p:nvSpPr>
-          <p:cNvPr id="91" name="Text 88"/>
-          <p:cNvSpPr txBox="1"/>
-          <p:nvPr/>
-        </p:nvSpPr>
-        <p:spPr>
-          <a:xfrm>
-            <a:off x="10707624" y="3090672"/>
+          <p:cNvPr id="115" name="Text 112"/>
+          <p:cNvSpPr txBox="1"/>
+          <p:nvPr/>
+        </p:nvSpPr>
+        <p:spPr>
+          <a:xfrm>
+            <a:off x="10232136" y="3090672"/>
             <a:ext cx="640080" cy="201168"/>
           </a:xfrm>
           <a:prstGeom prst="rect">
@@ -5883,7 +6819,46 @@
       </p:sp>
       <p:sp>
         <p:nvSpPr>
-          <p:cNvPr id="92" name="Shape 89"/>
+          <p:cNvPr id="116" name="Text 113"/>
+          <p:cNvSpPr txBox="1"/>
+          <p:nvPr/>
+        </p:nvSpPr>
+        <p:spPr>
+          <a:xfrm>
+            <a:off x="10945368" y="3090672"/>
+            <a:ext cx="402336" cy="201168"/>
+          </a:xfrm>
+          <a:prstGeom prst="rect">
+            <a:avLst/>
+          </a:prstGeom>
+          <a:noFill/>
+          <a:ln/>
+        </p:spPr>
+        <p:txBody>
+          <a:bodyPr wrap="square" lIns="0" tIns="0" rIns="0" bIns="0" rtlCol="0" anchor="ctr"/>
+          <a:lstStyle/>
+          <a:p>
+            <a:pPr algn="r" indent="0" marL="0">
+              <a:buNone/>
+            </a:pPr>
+            <a:r>
+              <a:rPr lang="en-US" sz="900" b="1" dirty="0">
+                <a:solidFill>
+                  <a:srgbClr val="E9A13B"/>
+                </a:solidFill>
+                <a:latin typeface="Calibri" pitchFamily="34" charset="0"/>
+                <a:ea typeface="Calibri" pitchFamily="34" charset="-122"/>
+                <a:cs typeface="Calibri" pitchFamily="34" charset="-120"/>
+              </a:rPr>
+              <a:t>05/10</a:t>
+            </a:r>
+            <a:endParaRPr lang="en-US" sz="900" dirty="0"/>
+          </a:p>
+        </p:txBody>
+      </p:sp>
+      <p:sp>
+        <p:nvSpPr>
+          <p:cNvPr id="117" name="Shape 114"/>
           <p:cNvSpPr/>
           <p:nvPr/>
         </p:nvSpPr>
@@ -5903,14 +6878,14 @@
       </p:sp>
       <p:sp>
         <p:nvSpPr>
-          <p:cNvPr id="93" name="Text 90"/>
+          <p:cNvPr id="118" name="Text 115"/>
           <p:cNvSpPr txBox="1"/>
           <p:nvPr/>
         </p:nvSpPr>
         <p:spPr>
           <a:xfrm>
             <a:off x="8595360" y="3291840"/>
-            <a:ext cx="2084832" cy="201168"/>
+            <a:ext cx="1581912" cy="201168"/>
           </a:xfrm>
           <a:prstGeom prst="rect">
             <a:avLst/>
@@ -5942,13 +6917,13 @@
       </p:sp>
       <p:sp>
         <p:nvSpPr>
-          <p:cNvPr id="94" name="Text 91"/>
-          <p:cNvSpPr txBox="1"/>
-          <p:nvPr/>
-        </p:nvSpPr>
-        <p:spPr>
-          <a:xfrm>
-            <a:off x="10707624" y="3291840"/>
+          <p:cNvPr id="119" name="Text 116"/>
+          <p:cNvSpPr txBox="1"/>
+          <p:nvPr/>
+        </p:nvSpPr>
+        <p:spPr>
+          <a:xfrm>
+            <a:off x="10232136" y="3291840"/>
             <a:ext cx="640080" cy="201168"/>
           </a:xfrm>
           <a:prstGeom prst="rect">
@@ -5981,7 +6956,46 @@
       </p:sp>
       <p:sp>
         <p:nvSpPr>
-          <p:cNvPr id="95" name="Shape 92"/>
+          <p:cNvPr id="120" name="Text 117"/>
+          <p:cNvSpPr txBox="1"/>
+          <p:nvPr/>
+        </p:nvSpPr>
+        <p:spPr>
+          <a:xfrm>
+            <a:off x="10945368" y="3291840"/>
+            <a:ext cx="402336" cy="201168"/>
+          </a:xfrm>
+          <a:prstGeom prst="rect">
+            <a:avLst/>
+          </a:prstGeom>
+          <a:noFill/>
+          <a:ln/>
+        </p:spPr>
+        <p:txBody>
+          <a:bodyPr wrap="square" lIns="0" tIns="0" rIns="0" bIns="0" rtlCol="0" anchor="ctr"/>
+          <a:lstStyle/>
+          <a:p>
+            <a:pPr algn="r" indent="0" marL="0">
+              <a:buNone/>
+            </a:pPr>
+            <a:r>
+              <a:rPr lang="en-US" sz="900" dirty="0">
+                <a:solidFill>
+                  <a:srgbClr val="93A9C6"/>
+                </a:solidFill>
+                <a:latin typeface="Calibri" pitchFamily="34" charset="0"/>
+                <a:ea typeface="Calibri" pitchFamily="34" charset="-122"/>
+                <a:cs typeface="Calibri" pitchFamily="34" charset="-120"/>
+              </a:rPr>
+              <a:t>08/10</a:t>
+            </a:r>
+            <a:endParaRPr lang="en-US" sz="900" dirty="0"/>
+          </a:p>
+        </p:txBody>
+      </p:sp>
+      <p:sp>
+        <p:nvSpPr>
+          <p:cNvPr id="121" name="Shape 118"/>
           <p:cNvSpPr/>
           <p:nvPr/>
         </p:nvSpPr>
@@ -6001,14 +7015,14 @@
       </p:sp>
       <p:sp>
         <p:nvSpPr>
-          <p:cNvPr id="96" name="Text 93"/>
+          <p:cNvPr id="122" name="Text 119"/>
           <p:cNvSpPr txBox="1"/>
           <p:nvPr/>
         </p:nvSpPr>
         <p:spPr>
           <a:xfrm>
             <a:off x="8595360" y="3493008"/>
-            <a:ext cx="2084832" cy="201168"/>
+            <a:ext cx="1581912" cy="201168"/>
           </a:xfrm>
           <a:prstGeom prst="rect">
             <a:avLst/>
@@ -6040,13 +7054,13 @@
       </p:sp>
       <p:sp>
         <p:nvSpPr>
-          <p:cNvPr id="97" name="Text 94"/>
-          <p:cNvSpPr txBox="1"/>
-          <p:nvPr/>
-        </p:nvSpPr>
-        <p:spPr>
-          <a:xfrm>
-            <a:off x="10707624" y="3493008"/>
+          <p:cNvPr id="123" name="Text 120"/>
+          <p:cNvSpPr txBox="1"/>
+          <p:nvPr/>
+        </p:nvSpPr>
+        <p:spPr>
+          <a:xfrm>
+            <a:off x="10232136" y="3493008"/>
             <a:ext cx="640080" cy="201168"/>
           </a:xfrm>
           <a:prstGeom prst="rect">
@@ -6079,7 +7093,46 @@
       </p:sp>
       <p:sp>
         <p:nvSpPr>
-          <p:cNvPr id="98" name="Shape 95"/>
+          <p:cNvPr id="124" name="Text 121"/>
+          <p:cNvSpPr txBox="1"/>
+          <p:nvPr/>
+        </p:nvSpPr>
+        <p:spPr>
+          <a:xfrm>
+            <a:off x="10945368" y="3493008"/>
+            <a:ext cx="402336" cy="201168"/>
+          </a:xfrm>
+          <a:prstGeom prst="rect">
+            <a:avLst/>
+          </a:prstGeom>
+          <a:noFill/>
+          <a:ln/>
+        </p:spPr>
+        <p:txBody>
+          <a:bodyPr wrap="square" lIns="0" tIns="0" rIns="0" bIns="0" rtlCol="0" anchor="ctr"/>
+          <a:lstStyle/>
+          <a:p>
+            <a:pPr algn="r" indent="0" marL="0">
+              <a:buNone/>
+            </a:pPr>
+            <a:r>
+              <a:rPr lang="en-US" sz="900" dirty="0">
+                <a:solidFill>
+                  <a:srgbClr val="93A9C6"/>
+                </a:solidFill>
+                <a:latin typeface="Calibri" pitchFamily="34" charset="0"/>
+                <a:ea typeface="Calibri" pitchFamily="34" charset="-122"/>
+                <a:cs typeface="Calibri" pitchFamily="34" charset="-120"/>
+              </a:rPr>
+              <a:t>08/10</a:t>
+            </a:r>
+            <a:endParaRPr lang="en-US" sz="900" dirty="0"/>
+          </a:p>
+        </p:txBody>
+      </p:sp>
+      <p:sp>
+        <p:nvSpPr>
+          <p:cNvPr id="125" name="Shape 122"/>
           <p:cNvSpPr/>
           <p:nvPr/>
         </p:nvSpPr>
@@ -6099,14 +7152,14 @@
       </p:sp>
       <p:sp>
         <p:nvSpPr>
-          <p:cNvPr id="99" name="Text 96"/>
+          <p:cNvPr id="126" name="Text 123"/>
           <p:cNvSpPr txBox="1"/>
           <p:nvPr/>
         </p:nvSpPr>
         <p:spPr>
           <a:xfrm>
             <a:off x="8595360" y="3694176"/>
-            <a:ext cx="2084832" cy="201168"/>
+            <a:ext cx="1581912" cy="201168"/>
           </a:xfrm>
           <a:prstGeom prst="rect">
             <a:avLst/>
@@ -6138,13 +7191,13 @@
       </p:sp>
       <p:sp>
         <p:nvSpPr>
-          <p:cNvPr id="100" name="Text 97"/>
-          <p:cNvSpPr txBox="1"/>
-          <p:nvPr/>
-        </p:nvSpPr>
-        <p:spPr>
-          <a:xfrm>
-            <a:off x="10707624" y="3694176"/>
+          <p:cNvPr id="127" name="Text 124"/>
+          <p:cNvSpPr txBox="1"/>
+          <p:nvPr/>
+        </p:nvSpPr>
+        <p:spPr>
+          <a:xfrm>
+            <a:off x="10232136" y="3694176"/>
             <a:ext cx="640080" cy="201168"/>
           </a:xfrm>
           <a:prstGeom prst="rect">
@@ -6177,14 +7230,53 @@
       </p:sp>
       <p:sp>
         <p:nvSpPr>
-          <p:cNvPr id="101" name="Text 98"/>
+          <p:cNvPr id="128" name="Text 125"/>
+          <p:cNvSpPr txBox="1"/>
+          <p:nvPr/>
+        </p:nvSpPr>
+        <p:spPr>
+          <a:xfrm>
+            <a:off x="10945368" y="3694176"/>
+            <a:ext cx="402336" cy="201168"/>
+          </a:xfrm>
+          <a:prstGeom prst="rect">
+            <a:avLst/>
+          </a:prstGeom>
+          <a:noFill/>
+          <a:ln/>
+        </p:spPr>
+        <p:txBody>
+          <a:bodyPr wrap="square" lIns="0" tIns="0" rIns="0" bIns="0" rtlCol="0" anchor="ctr"/>
+          <a:lstStyle/>
+          <a:p>
+            <a:pPr algn="r" indent="0" marL="0">
+              <a:buNone/>
+            </a:pPr>
+            <a:r>
+              <a:rPr lang="en-US" sz="900" dirty="0">
+                <a:solidFill>
+                  <a:srgbClr val="93A9C6"/>
+                </a:solidFill>
+                <a:latin typeface="Calibri" pitchFamily="34" charset="0"/>
+                <a:ea typeface="Calibri" pitchFamily="34" charset="-122"/>
+                <a:cs typeface="Calibri" pitchFamily="34" charset="-120"/>
+              </a:rPr>
+              <a:t>08/10</a:t>
+            </a:r>
+            <a:endParaRPr lang="en-US" sz="900" dirty="0"/>
+          </a:p>
+        </p:txBody>
+      </p:sp>
+      <p:sp>
+        <p:nvSpPr>
+          <p:cNvPr id="129" name="Text 126"/>
           <p:cNvSpPr txBox="1"/>
           <p:nvPr/>
         </p:nvSpPr>
         <p:spPr>
           <a:xfrm>
             <a:off x="8394192" y="3931920"/>
-            <a:ext cx="2953512" cy="201168"/>
+            <a:ext cx="1947672" cy="201168"/>
           </a:xfrm>
           <a:prstGeom prst="rect">
             <a:avLst/>
@@ -6216,7 +7308,7 @@
       </p:sp>
       <p:sp>
         <p:nvSpPr>
-          <p:cNvPr id="102" name="Shape 99"/>
+          <p:cNvPr id="130" name="Shape 127"/>
           <p:cNvSpPr/>
           <p:nvPr/>
         </p:nvSpPr>
@@ -6238,14 +7330,14 @@
       </p:sp>
       <p:sp>
         <p:nvSpPr>
-          <p:cNvPr id="103" name="Text 100"/>
+          <p:cNvPr id="131" name="Text 128"/>
           <p:cNvSpPr txBox="1"/>
           <p:nvPr/>
         </p:nvSpPr>
         <p:spPr>
           <a:xfrm>
             <a:off x="8595360" y="4151376"/>
-            <a:ext cx="2084832" cy="201168"/>
+            <a:ext cx="1581912" cy="201168"/>
           </a:xfrm>
           <a:prstGeom prst="rect">
             <a:avLst/>
@@ -6277,13 +7369,13 @@
       </p:sp>
       <p:sp>
         <p:nvSpPr>
-          <p:cNvPr id="104" name="Text 101"/>
-          <p:cNvSpPr txBox="1"/>
-          <p:nvPr/>
-        </p:nvSpPr>
-        <p:spPr>
-          <a:xfrm>
-            <a:off x="10707624" y="4151376"/>
+          <p:cNvPr id="132" name="Text 129"/>
+          <p:cNvSpPr txBox="1"/>
+          <p:nvPr/>
+        </p:nvSpPr>
+        <p:spPr>
+          <a:xfrm>
+            <a:off x="10232136" y="4151376"/>
             <a:ext cx="640080" cy="201168"/>
           </a:xfrm>
           <a:prstGeom prst="rect">
@@ -6316,7 +7408,46 @@
       </p:sp>
       <p:sp>
         <p:nvSpPr>
-          <p:cNvPr id="105" name="Shape 102"/>
+          <p:cNvPr id="133" name="Text 130"/>
+          <p:cNvSpPr txBox="1"/>
+          <p:nvPr/>
+        </p:nvSpPr>
+        <p:spPr>
+          <a:xfrm>
+            <a:off x="10945368" y="4151376"/>
+            <a:ext cx="402336" cy="201168"/>
+          </a:xfrm>
+          <a:prstGeom prst="rect">
+            <a:avLst/>
+          </a:prstGeom>
+          <a:noFill/>
+          <a:ln/>
+        </p:spPr>
+        <p:txBody>
+          <a:bodyPr wrap="square" lIns="0" tIns="0" rIns="0" bIns="0" rtlCol="0" anchor="ctr"/>
+          <a:lstStyle/>
+          <a:p>
+            <a:pPr algn="r" indent="0" marL="0">
+              <a:buNone/>
+            </a:pPr>
+            <a:r>
+              <a:rPr lang="en-US" sz="900" b="1" dirty="0">
+                <a:solidFill>
+                  <a:srgbClr val="E9A13B"/>
+                </a:solidFill>
+                <a:latin typeface="Calibri" pitchFamily="34" charset="0"/>
+                <a:ea typeface="Calibri" pitchFamily="34" charset="-122"/>
+                <a:cs typeface="Calibri" pitchFamily="34" charset="-120"/>
+              </a:rPr>
+              <a:t>05/10</a:t>
+            </a:r>
+            <a:endParaRPr lang="en-US" sz="900" dirty="0"/>
+          </a:p>
+        </p:txBody>
+      </p:sp>
+      <p:sp>
+        <p:nvSpPr>
+          <p:cNvPr id="134" name="Shape 131"/>
           <p:cNvSpPr/>
           <p:nvPr/>
         </p:nvSpPr>
@@ -6338,14 +7469,14 @@
       </p:sp>
       <p:sp>
         <p:nvSpPr>
-          <p:cNvPr id="106" name="Text 103"/>
+          <p:cNvPr id="135" name="Text 132"/>
           <p:cNvSpPr txBox="1"/>
           <p:nvPr/>
         </p:nvSpPr>
         <p:spPr>
           <a:xfrm>
             <a:off x="8595360" y="4352544"/>
-            <a:ext cx="2084832" cy="201168"/>
+            <a:ext cx="1581912" cy="201168"/>
           </a:xfrm>
           <a:prstGeom prst="rect">
             <a:avLst/>
@@ -6377,13 +7508,13 @@
       </p:sp>
       <p:sp>
         <p:nvSpPr>
-          <p:cNvPr id="107" name="Text 104"/>
-          <p:cNvSpPr txBox="1"/>
-          <p:nvPr/>
-        </p:nvSpPr>
-        <p:spPr>
-          <a:xfrm>
-            <a:off x="10707624" y="4352544"/>
+          <p:cNvPr id="136" name="Text 133"/>
+          <p:cNvSpPr txBox="1"/>
+          <p:nvPr/>
+        </p:nvSpPr>
+        <p:spPr>
+          <a:xfrm>
+            <a:off x="10232136" y="4352544"/>
             <a:ext cx="640080" cy="201168"/>
           </a:xfrm>
           <a:prstGeom prst="rect">
@@ -6416,14 +7547,53 @@
       </p:sp>
       <p:sp>
         <p:nvSpPr>
-          <p:cNvPr id="108" name="Text 105"/>
+          <p:cNvPr id="137" name="Text 134"/>
+          <p:cNvSpPr txBox="1"/>
+          <p:nvPr/>
+        </p:nvSpPr>
+        <p:spPr>
+          <a:xfrm>
+            <a:off x="10945368" y="4352544"/>
+            <a:ext cx="402336" cy="201168"/>
+          </a:xfrm>
+          <a:prstGeom prst="rect">
+            <a:avLst/>
+          </a:prstGeom>
+          <a:noFill/>
+          <a:ln/>
+        </p:spPr>
+        <p:txBody>
+          <a:bodyPr wrap="square" lIns="0" tIns="0" rIns="0" bIns="0" rtlCol="0" anchor="ctr"/>
+          <a:lstStyle/>
+          <a:p>
+            <a:pPr algn="r" indent="0" marL="0">
+              <a:buNone/>
+            </a:pPr>
+            <a:r>
+              <a:rPr lang="en-US" sz="900" b="1" dirty="0">
+                <a:solidFill>
+                  <a:srgbClr val="E9A13B"/>
+                </a:solidFill>
+                <a:latin typeface="Calibri" pitchFamily="34" charset="0"/>
+                <a:ea typeface="Calibri" pitchFamily="34" charset="-122"/>
+                <a:cs typeface="Calibri" pitchFamily="34" charset="-120"/>
+              </a:rPr>
+              <a:t>05/10</a:t>
+            </a:r>
+            <a:endParaRPr lang="en-US" sz="900" dirty="0"/>
+          </a:p>
+        </p:txBody>
+      </p:sp>
+      <p:sp>
+        <p:nvSpPr>
+          <p:cNvPr id="138" name="Text 135"/>
           <p:cNvSpPr txBox="1"/>
           <p:nvPr/>
         </p:nvSpPr>
         <p:spPr>
           <a:xfrm>
             <a:off x="8394192" y="4590288"/>
-            <a:ext cx="2953512" cy="201168"/>
+            <a:ext cx="1947672" cy="201168"/>
           </a:xfrm>
           <a:prstGeom prst="rect">
             <a:avLst/>
@@ -6455,7 +7625,7 @@
       </p:sp>
       <p:sp>
         <p:nvSpPr>
-          <p:cNvPr id="109" name="Shape 106"/>
+          <p:cNvPr id="139" name="Shape 136"/>
           <p:cNvSpPr/>
           <p:nvPr/>
         </p:nvSpPr>
@@ -6475,14 +7645,14 @@
       </p:sp>
       <p:sp>
         <p:nvSpPr>
-          <p:cNvPr id="110" name="Text 107"/>
+          <p:cNvPr id="140" name="Text 137"/>
           <p:cNvSpPr txBox="1"/>
           <p:nvPr/>
         </p:nvSpPr>
         <p:spPr>
           <a:xfrm>
             <a:off x="8595360" y="4809744"/>
-            <a:ext cx="2084832" cy="201168"/>
+            <a:ext cx="1581912" cy="201168"/>
           </a:xfrm>
           <a:prstGeom prst="rect">
             <a:avLst/>
@@ -6514,13 +7684,13 @@
       </p:sp>
       <p:sp>
         <p:nvSpPr>
-          <p:cNvPr id="111" name="Text 108"/>
-          <p:cNvSpPr txBox="1"/>
-          <p:nvPr/>
-        </p:nvSpPr>
-        <p:spPr>
-          <a:xfrm>
-            <a:off x="10707624" y="4809744"/>
+          <p:cNvPr id="141" name="Text 138"/>
+          <p:cNvSpPr txBox="1"/>
+          <p:nvPr/>
+        </p:nvSpPr>
+        <p:spPr>
+          <a:xfrm>
+            <a:off x="10232136" y="4809744"/>
             <a:ext cx="640080" cy="201168"/>
           </a:xfrm>
           <a:prstGeom prst="rect">
@@ -6553,7 +7723,46 @@
       </p:sp>
       <p:sp>
         <p:nvSpPr>
-          <p:cNvPr id="112" name="Shape 109"/>
+          <p:cNvPr id="142" name="Text 139"/>
+          <p:cNvSpPr txBox="1"/>
+          <p:nvPr/>
+        </p:nvSpPr>
+        <p:spPr>
+          <a:xfrm>
+            <a:off x="10945368" y="4809744"/>
+            <a:ext cx="402336" cy="201168"/>
+          </a:xfrm>
+          <a:prstGeom prst="rect">
+            <a:avLst/>
+          </a:prstGeom>
+          <a:noFill/>
+          <a:ln/>
+        </p:spPr>
+        <p:txBody>
+          <a:bodyPr wrap="square" lIns="0" tIns="0" rIns="0" bIns="0" rtlCol="0" anchor="ctr"/>
+          <a:lstStyle/>
+          <a:p>
+            <a:pPr algn="r" indent="0" marL="0">
+              <a:buNone/>
+            </a:pPr>
+            <a:r>
+              <a:rPr lang="en-US" sz="900" dirty="0">
+                <a:solidFill>
+                  <a:srgbClr val="93A9C6"/>
+                </a:solidFill>
+                <a:latin typeface="Calibri" pitchFamily="34" charset="0"/>
+                <a:ea typeface="Calibri" pitchFamily="34" charset="-122"/>
+                <a:cs typeface="Calibri" pitchFamily="34" charset="-120"/>
+              </a:rPr>
+              <a:t>08/10</a:t>
+            </a:r>
+            <a:endParaRPr lang="en-US" sz="900" dirty="0"/>
+          </a:p>
+        </p:txBody>
+      </p:sp>
+      <p:sp>
+        <p:nvSpPr>
+          <p:cNvPr id="143" name="Shape 140"/>
           <p:cNvSpPr/>
           <p:nvPr/>
         </p:nvSpPr>
@@ -6573,14 +7782,14 @@
       </p:sp>
       <p:sp>
         <p:nvSpPr>
-          <p:cNvPr id="113" name="Text 110"/>
+          <p:cNvPr id="144" name="Text 141"/>
           <p:cNvSpPr txBox="1"/>
           <p:nvPr/>
         </p:nvSpPr>
         <p:spPr>
           <a:xfrm>
             <a:off x="8595360" y="5010912"/>
-            <a:ext cx="2084832" cy="201168"/>
+            <a:ext cx="1581912" cy="201168"/>
           </a:xfrm>
           <a:prstGeom prst="rect">
             <a:avLst/>
@@ -6612,13 +7821,13 @@
       </p:sp>
       <p:sp>
         <p:nvSpPr>
-          <p:cNvPr id="114" name="Text 111"/>
-          <p:cNvSpPr txBox="1"/>
-          <p:nvPr/>
-        </p:nvSpPr>
-        <p:spPr>
-          <a:xfrm>
-            <a:off x="10707624" y="5010912"/>
+          <p:cNvPr id="145" name="Text 142"/>
+          <p:cNvSpPr txBox="1"/>
+          <p:nvPr/>
+        </p:nvSpPr>
+        <p:spPr>
+          <a:xfrm>
+            <a:off x="10232136" y="5010912"/>
             <a:ext cx="640080" cy="201168"/>
           </a:xfrm>
           <a:prstGeom prst="rect">
@@ -6651,7 +7860,46 @@
       </p:sp>
       <p:sp>
         <p:nvSpPr>
-          <p:cNvPr id="115" name="Shape 112"/>
+          <p:cNvPr id="146" name="Text 143"/>
+          <p:cNvSpPr txBox="1"/>
+          <p:nvPr/>
+        </p:nvSpPr>
+        <p:spPr>
+          <a:xfrm>
+            <a:off x="10945368" y="5010912"/>
+            <a:ext cx="402336" cy="201168"/>
+          </a:xfrm>
+          <a:prstGeom prst="rect">
+            <a:avLst/>
+          </a:prstGeom>
+          <a:noFill/>
+          <a:ln/>
+        </p:spPr>
+        <p:txBody>
+          <a:bodyPr wrap="square" lIns="0" tIns="0" rIns="0" bIns="0" rtlCol="0" anchor="ctr"/>
+          <a:lstStyle/>
+          <a:p>
+            <a:pPr algn="r" indent="0" marL="0">
+              <a:buNone/>
+            </a:pPr>
+            <a:r>
+              <a:rPr lang="en-US" sz="900" dirty="0">
+                <a:solidFill>
+                  <a:srgbClr val="93A9C6"/>
+                </a:solidFill>
+                <a:latin typeface="Calibri" pitchFamily="34" charset="0"/>
+                <a:ea typeface="Calibri" pitchFamily="34" charset="-122"/>
+                <a:cs typeface="Calibri" pitchFamily="34" charset="-120"/>
+              </a:rPr>
+              <a:t>08/10</a:t>
+            </a:r>
+            <a:endParaRPr lang="en-US" sz="900" dirty="0"/>
+          </a:p>
+        </p:txBody>
+      </p:sp>
+      <p:sp>
+        <p:nvSpPr>
+          <p:cNvPr id="147" name="Shape 144"/>
           <p:cNvSpPr/>
           <p:nvPr/>
         </p:nvSpPr>
@@ -6671,14 +7919,14 @@
       </p:sp>
       <p:sp>
         <p:nvSpPr>
-          <p:cNvPr id="116" name="Text 113"/>
+          <p:cNvPr id="148" name="Text 145"/>
           <p:cNvSpPr txBox="1"/>
           <p:nvPr/>
         </p:nvSpPr>
         <p:spPr>
           <a:xfrm>
             <a:off x="8595360" y="5212080"/>
-            <a:ext cx="2084832" cy="201168"/>
+            <a:ext cx="1581912" cy="201168"/>
           </a:xfrm>
           <a:prstGeom prst="rect">
             <a:avLst/>
@@ -6710,13 +7958,13 @@
       </p:sp>
       <p:sp>
         <p:nvSpPr>
-          <p:cNvPr id="117" name="Text 114"/>
-          <p:cNvSpPr txBox="1"/>
-          <p:nvPr/>
-        </p:nvSpPr>
-        <p:spPr>
-          <a:xfrm>
-            <a:off x="10707624" y="5212080"/>
+          <p:cNvPr id="149" name="Text 146"/>
+          <p:cNvSpPr txBox="1"/>
+          <p:nvPr/>
+        </p:nvSpPr>
+        <p:spPr>
+          <a:xfrm>
+            <a:off x="10232136" y="5212080"/>
             <a:ext cx="640080" cy="201168"/>
           </a:xfrm>
           <a:prstGeom prst="rect">
@@ -6749,7 +7997,46 @@
       </p:sp>
       <p:sp>
         <p:nvSpPr>
-          <p:cNvPr id="118" name="Shape 115"/>
+          <p:cNvPr id="150" name="Text 147"/>
+          <p:cNvSpPr txBox="1"/>
+          <p:nvPr/>
+        </p:nvSpPr>
+        <p:spPr>
+          <a:xfrm>
+            <a:off x="10945368" y="5212080"/>
+            <a:ext cx="402336" cy="201168"/>
+          </a:xfrm>
+          <a:prstGeom prst="rect">
+            <a:avLst/>
+          </a:prstGeom>
+          <a:noFill/>
+          <a:ln/>
+        </p:spPr>
+        <p:txBody>
+          <a:bodyPr wrap="square" lIns="0" tIns="0" rIns="0" bIns="0" rtlCol="0" anchor="ctr"/>
+          <a:lstStyle/>
+          <a:p>
+            <a:pPr algn="r" indent="0" marL="0">
+              <a:buNone/>
+            </a:pPr>
+            <a:r>
+              <a:rPr lang="en-US" sz="900" dirty="0">
+                <a:solidFill>
+                  <a:srgbClr val="93A9C6"/>
+                </a:solidFill>
+                <a:latin typeface="Calibri" pitchFamily="34" charset="0"/>
+                <a:ea typeface="Calibri" pitchFamily="34" charset="-122"/>
+                <a:cs typeface="Calibri" pitchFamily="34" charset="-120"/>
+              </a:rPr>
+              <a:t>08/10</a:t>
+            </a:r>
+            <a:endParaRPr lang="en-US" sz="900" dirty="0"/>
+          </a:p>
+        </p:txBody>
+      </p:sp>
+      <p:sp>
+        <p:nvSpPr>
+          <p:cNvPr id="151" name="Shape 148"/>
           <p:cNvSpPr/>
           <p:nvPr/>
         </p:nvSpPr>
@@ -6778,7 +8065,7 @@
       </p:sp>
       <p:sp>
         <p:nvSpPr>
-          <p:cNvPr id="119" name="Text 116"/>
+          <p:cNvPr id="152" name="Text 149"/>
           <p:cNvSpPr txBox="1"/>
           <p:nvPr/>
         </p:nvSpPr>
@@ -6837,7 +8124,7 @@
                 <a:ea typeface="Calibri" pitchFamily="34" charset="-122"/>
                 <a:cs typeface="Calibri" pitchFamily="34" charset="-120"/>
               </a:rPr>
-              <a:t>        FOCAIS   </a:t>
+              <a:t>          PRAZO EM ÂMBAR   </a:t>
             </a:r>
             <a:pPr indent="0" marL="0">
               <a:buNone/>
@@ -6851,7 +8138,7 @@
                 <a:ea typeface="Calibri" pitchFamily="34" charset="-122"/>
                 <a:cs typeface="Calibri" pitchFamily="34" charset="-120"/>
               </a:rPr>
-              <a:t>Willyan  ·  Deyvid  ·  Andressa  ·  Cliente</a:t>
+              <a:t>métrica ainda em andamento</a:t>
             </a:r>
             <a:endParaRPr lang="en-US" sz="900" dirty="0"/>
           </a:p>

</xml_diff>